<commit_message>
Clarify UML generation and regression evidence
</commit_message>
<xml_diff>
--- a/TPO-Ajedrez-2026/docs/presentacion-tpo.pptx
+++ b/TPO-Ajedrez-2026/docs/presentacion-tpo.pptx
@@ -11490,7 +11490,7 @@
                 <a:ea typeface="Arial"/>
                 <a:cs typeface="Arial"/>
               </a:rPr>
-              <a:t>El diagrama completo se regenera desde el código con docs/generar_uml.py.</a:t>
+              <a:t>El generador usa una definición manual que debe mantenerse sincronizada con el código.</a:t>
             </a:r>
           </a:p>
         </p:txBody>
@@ -15184,7 +15184,7 @@
                 <a:ea typeface="Arial"/>
                 <a:cs typeface="Arial"/>
               </a:rPr>
-              <a:t>La prueba nueva encontró el defecto antes de corregirlo.</a:t>
+              <a:t>La prueba de regresión cubre esta regla.</a:t>
             </a:r>
           </a:p>
         </p:txBody>

</xml_diff>

<commit_message>
Complete chess TPO presentation and traceability
</commit_message>
<xml_diff>
--- a/TPO-Ajedrez-2026/docs/presentacion-tpo.pptx
+++ b/TPO-Ajedrez-2026/docs/presentacion-tpo.pptx
@@ -16,6 +16,7 @@
     <p:sldId xmlns:r="http://schemas.openxmlformats.org/officeDocument/2006/relationships" id="261" r:id="R3f731650e9fa4512"/>
     <p:sldId xmlns:r="http://schemas.openxmlformats.org/officeDocument/2006/relationships" id="262" r:id="R3c18b12e5e054791"/>
     <p:sldId xmlns:r="http://schemas.openxmlformats.org/officeDocument/2006/relationships" id="263" r:id="R691f392216224be6"/>
+    <p:sldId xmlns:ns0="http://schemas.openxmlformats.org/officeDocument/2006/relationships" id="264" ns0:id="rId14"/>
   </p:sldIdLst>
   <p:sldSz cx="12192000" cy="6858000"/>
   <p:notesSz cx="6858000" cy="9144000"/>
@@ -3963,6 +3964,10 @@
             <a:prstDash val="solid"/>
           </a:ln>
         </p:spPr>
+        <p:txBody xmlns:a="http://schemas.openxmlformats.org/drawingml/2006/main">
+          <a:bodyPr/>
+          <a:p/>
+        </p:txBody>
       </p:sp>
       <p:sp>
         <p:nvSpPr>
@@ -4332,6 +4337,10 @@
             <a:prstDash val="solid"/>
           </a:ln>
         </p:spPr>
+        <p:txBody xmlns:a="http://schemas.openxmlformats.org/drawingml/2006/main">
+          <a:bodyPr/>
+          <a:p/>
+        </p:txBody>
       </p:sp>
       <p:sp>
         <p:nvSpPr>
@@ -4646,27 +4655,14 @@
             </a:lvl9pPr>
           </a:lstStyle>
           <a:p xmlns:a="http://schemas.openxmlformats.org/drawingml/2006/main">
-            <a:pPr>
-              <a:buNone/>
-              <a:defRPr sz="1275" b="0">
-                <a:solidFill>
-                  <a:srgbClr val="C5D0D5"/>
-                </a:solidFill>
-                <a:latin typeface="Arial"/>
-                <a:ea typeface="Arial"/>
-                <a:cs typeface="Arial"/>
-              </a:defRPr>
-            </a:pPr>
             <a:r>
-              <a:rPr sz="1275" b="0">
-                <a:solidFill>
-                  <a:srgbClr val="C5D0D5"/>
-                </a:solidFill>
-                <a:latin typeface="Arial"/>
-                <a:ea typeface="Arial"/>
-                <a:cs typeface="Arial"/>
+              <a:rPr sz="1000">
+                <a:solidFill>
+                  <a:srgbClr val="AAAAAA"/>
+                </a:solidFill>
+                <a:latin typeface="Arial"/>
               </a:rPr>
-              <a:t>Proyecto académico · 2026</a:t>
+              <a:t>Proyecto académico · 2026 · Grupo de seis con autorización informada por el grupo</a:t>
             </a:r>
           </a:p>
         </p:txBody>
@@ -7950,6 +7946,10 @@
             <a:prstDash val="solid"/>
           </a:ln>
         </p:spPr>
+        <p:txBody xmlns:a="http://schemas.openxmlformats.org/drawingml/2006/main">
+          <a:bodyPr/>
+          <a:p/>
+        </p:txBody>
       </p:sp>
       <p:sp>
         <p:nvSpPr>
@@ -8150,6 +8150,10 @@
             <a:prstDash val="solid"/>
           </a:ln>
         </p:spPr>
+        <p:txBody xmlns:a="http://schemas.openxmlformats.org/drawingml/2006/main">
+          <a:bodyPr/>
+          <a:p/>
+        </p:txBody>
       </p:sp>
       <p:sp>
         <p:nvSpPr>
@@ -8521,6 +8525,10 @@
             <a:prstDash val="solid"/>
           </a:ln>
         </p:spPr>
+        <p:txBody xmlns:a="http://schemas.openxmlformats.org/drawingml/2006/main">
+          <a:bodyPr/>
+          <a:p/>
+        </p:txBody>
       </p:sp>
       <p:sp>
         <p:nvSpPr>
@@ -8916,6 +8924,10 @@
             <a:prstDash val="solid"/>
           </a:ln>
         </p:spPr>
+        <p:txBody xmlns:a="http://schemas.openxmlformats.org/drawingml/2006/main">
+          <a:bodyPr/>
+          <a:p/>
+        </p:txBody>
       </p:sp>
       <p:sp>
         <p:nvSpPr>
@@ -9311,6 +9323,10 @@
             <a:prstDash val="solid"/>
           </a:ln>
         </p:spPr>
+        <p:txBody xmlns:a="http://schemas.openxmlformats.org/drawingml/2006/main">
+          <a:bodyPr/>
+          <a:p/>
+        </p:txBody>
       </p:sp>
       <p:sp>
         <p:nvSpPr>
@@ -9706,6 +9722,10 @@
             <a:prstDash val="solid"/>
           </a:ln>
         </p:spPr>
+        <p:txBody xmlns:a="http://schemas.openxmlformats.org/drawingml/2006/main">
+          <a:bodyPr/>
+          <a:p/>
+        </p:txBody>
       </p:sp>
       <p:sp>
         <p:nvSpPr>
@@ -10101,6 +10121,10 @@
             <a:prstDash val="solid"/>
           </a:ln>
         </p:spPr>
+        <p:txBody xmlns:a="http://schemas.openxmlformats.org/drawingml/2006/main">
+          <a:bodyPr/>
+          <a:p/>
+        </p:txBody>
       </p:sp>
       <p:sp>
         <p:nvSpPr>
@@ -10494,37 +10518,10 @@
             <a:prstDash val="solid"/>
           </a:ln>
         </p:spPr>
-      </p:sp>
-      <p:sp>
-        <p:nvSpPr>
-          <p:cNvPr id="22" name="">
-            <a:extLst xmlns:a="http://schemas.openxmlformats.org/drawingml/2006/main">
-              <a:ext uri="{FF2B5EF4-FFF2-40B4-BE49-F238E27FC236}">
-                <a16:creationId xmlns:a16="http://schemas.microsoft.com/office/drawing/2014/main" id="{652AFDF7-F660-4CBA-A4EB-12F3EEED1266}"/>
-              </a:ext>
-            </a:extLst>
-          </p:cNvPr>
-          <p:cNvSpPr>
-            <a:spLocks xmlns:a="http://schemas.openxmlformats.org/drawingml/2006/main" noGrp="1"/>
-          </p:cNvSpPr>
-          <p:nvPr/>
-        </p:nvSpPr>
-        <p:spPr>
-          <a:xfrm xmlns:a="http://schemas.openxmlformats.org/drawingml/2006/main">
-            <a:off x="7524750" y="2686050"/>
-            <a:ext cx="933450" cy="28575"/>
-          </a:xfrm>
-          <a:prstGeom xmlns:a="http://schemas.openxmlformats.org/drawingml/2006/main" prst="rect">
-            <a:avLst/>
-          </a:prstGeom>
-          <a:solidFill xmlns:a="http://schemas.openxmlformats.org/drawingml/2006/main">
-            <a:srgbClr val="555555"/>
-          </a:solidFill>
-          <a:ln xmlns:a="http://schemas.openxmlformats.org/drawingml/2006/main" w="0">
-            <a:noFill/>
-            <a:prstDash val="solid"/>
-          </a:ln>
-        </p:spPr>
+        <p:txBody xmlns:a="http://schemas.openxmlformats.org/drawingml/2006/main">
+          <a:bodyPr/>
+          <a:p/>
+        </p:txBody>
       </p:sp>
       <p:sp>
         <p:nvSpPr>
@@ -10556,6 +10553,10 @@
             <a:prstDash val="solid"/>
           </a:ln>
         </p:spPr>
+        <p:txBody xmlns:a="http://schemas.openxmlformats.org/drawingml/2006/main">
+          <a:bodyPr/>
+          <a:p/>
+        </p:txBody>
       </p:sp>
       <p:sp>
         <p:nvSpPr>
@@ -10587,6 +10588,10 @@
             <a:prstDash val="solid"/>
           </a:ln>
         </p:spPr>
+        <p:txBody xmlns:a="http://schemas.openxmlformats.org/drawingml/2006/main">
+          <a:bodyPr/>
+          <a:p/>
+        </p:txBody>
       </p:sp>
       <p:sp>
         <p:nvSpPr>
@@ -10618,6 +10623,10 @@
             <a:prstDash val="solid"/>
           </a:ln>
         </p:spPr>
+        <p:txBody xmlns:a="http://schemas.openxmlformats.org/drawingml/2006/main">
+          <a:bodyPr/>
+          <a:p/>
+        </p:txBody>
       </p:sp>
       <p:sp>
         <p:nvSpPr>
@@ -10649,6 +10658,10 @@
             <a:prstDash val="solid"/>
           </a:ln>
         </p:spPr>
+        <p:txBody xmlns:a="http://schemas.openxmlformats.org/drawingml/2006/main">
+          <a:bodyPr/>
+          <a:p/>
+        </p:txBody>
       </p:sp>
       <p:sp>
         <p:nvSpPr>
@@ -10667,175 +10680,6 @@
         <p:spPr>
           <a:xfrm xmlns:a="http://schemas.openxmlformats.org/drawingml/2006/main">
             <a:off x="3981450" y="2447925"/>
-            <a:ext cx="457200" cy="209550"/>
-          </a:xfrm>
-          <a:prstGeom xmlns:a="http://schemas.openxmlformats.org/drawingml/2006/main" prst="rect">
-            <a:avLst/>
-          </a:prstGeom>
-          <a:noFill xmlns:a="http://schemas.openxmlformats.org/drawingml/2006/main"/>
-          <a:ln xmlns:a="http://schemas.openxmlformats.org/drawingml/2006/main" w="0">
-            <a:noFill/>
-            <a:prstDash val="solid"/>
-          </a:ln>
-        </p:spPr>
-        <p:txBody>
-          <a:bodyPr xmlns:a="http://schemas.openxmlformats.org/drawingml/2006/main" wrap="square" lIns="0" tIns="0" rIns="0" bIns="0" anchor="ctr">
-            <a:normAutofit fontScale="100000"/>
-          </a:bodyPr>
-          <a:lstStyle xmlns:a="http://schemas.openxmlformats.org/drawingml/2006/main">
-            <a:defPPr>
-              <a:defRPr sz="1125" b="1">
-                <a:solidFill>
-                  <a:srgbClr val="3A3A3A"/>
-                </a:solidFill>
-                <a:latin typeface="Arial"/>
-                <a:ea typeface="Arial"/>
-                <a:cs typeface="Arial"/>
-              </a:defRPr>
-            </a:defPPr>
-            <a:lvl1pPr>
-              <a:buNone/>
-              <a:defRPr sz="1125" b="1">
-                <a:solidFill>
-                  <a:srgbClr val="3A3A3A"/>
-                </a:solidFill>
-                <a:latin typeface="Arial"/>
-                <a:ea typeface="Arial"/>
-                <a:cs typeface="Arial"/>
-              </a:defRPr>
-            </a:lvl1pPr>
-            <a:lvl2pPr>
-              <a:buNone/>
-              <a:defRPr sz="1125" b="1">
-                <a:solidFill>
-                  <a:srgbClr val="3A3A3A"/>
-                </a:solidFill>
-                <a:latin typeface="Arial"/>
-                <a:ea typeface="Arial"/>
-                <a:cs typeface="Arial"/>
-              </a:defRPr>
-            </a:lvl2pPr>
-            <a:lvl3pPr>
-              <a:buNone/>
-              <a:defRPr sz="1125" b="1">
-                <a:solidFill>
-                  <a:srgbClr val="3A3A3A"/>
-                </a:solidFill>
-                <a:latin typeface="Arial"/>
-                <a:ea typeface="Arial"/>
-                <a:cs typeface="Arial"/>
-              </a:defRPr>
-            </a:lvl3pPr>
-            <a:lvl4pPr>
-              <a:buNone/>
-              <a:defRPr sz="1125" b="1">
-                <a:solidFill>
-                  <a:srgbClr val="3A3A3A"/>
-                </a:solidFill>
-                <a:latin typeface="Arial"/>
-                <a:ea typeface="Arial"/>
-                <a:cs typeface="Arial"/>
-              </a:defRPr>
-            </a:lvl4pPr>
-            <a:lvl5pPr>
-              <a:buNone/>
-              <a:defRPr sz="1125" b="1">
-                <a:solidFill>
-                  <a:srgbClr val="3A3A3A"/>
-                </a:solidFill>
-                <a:latin typeface="Arial"/>
-                <a:ea typeface="Arial"/>
-                <a:cs typeface="Arial"/>
-              </a:defRPr>
-            </a:lvl5pPr>
-            <a:lvl6pPr>
-              <a:buNone/>
-              <a:defRPr sz="1125" b="1">
-                <a:solidFill>
-                  <a:srgbClr val="3A3A3A"/>
-                </a:solidFill>
-                <a:latin typeface="Arial"/>
-                <a:ea typeface="Arial"/>
-                <a:cs typeface="Arial"/>
-              </a:defRPr>
-            </a:lvl6pPr>
-            <a:lvl7pPr>
-              <a:buNone/>
-              <a:defRPr sz="1125" b="1">
-                <a:solidFill>
-                  <a:srgbClr val="3A3A3A"/>
-                </a:solidFill>
-                <a:latin typeface="Arial"/>
-                <a:ea typeface="Arial"/>
-                <a:cs typeface="Arial"/>
-              </a:defRPr>
-            </a:lvl7pPr>
-            <a:lvl8pPr>
-              <a:buNone/>
-              <a:defRPr sz="1125" b="1">
-                <a:solidFill>
-                  <a:srgbClr val="3A3A3A"/>
-                </a:solidFill>
-                <a:latin typeface="Arial"/>
-                <a:ea typeface="Arial"/>
-                <a:cs typeface="Arial"/>
-              </a:defRPr>
-            </a:lvl8pPr>
-            <a:lvl9pPr>
-              <a:buNone/>
-              <a:defRPr sz="1125" b="1">
-                <a:solidFill>
-                  <a:srgbClr val="3A3A3A"/>
-                </a:solidFill>
-                <a:latin typeface="Arial"/>
-                <a:ea typeface="Arial"/>
-                <a:cs typeface="Arial"/>
-              </a:defRPr>
-            </a:lvl9pPr>
-          </a:lstStyle>
-          <a:p xmlns:a="http://schemas.openxmlformats.org/drawingml/2006/main">
-            <a:pPr>
-              <a:buNone/>
-              <a:defRPr sz="1125" b="1">
-                <a:solidFill>
-                  <a:srgbClr val="3A3A3A"/>
-                </a:solidFill>
-                <a:latin typeface="Arial"/>
-                <a:ea typeface="Arial"/>
-                <a:cs typeface="Arial"/>
-              </a:defRPr>
-            </a:pPr>
-            <a:r>
-              <a:rPr sz="1125" b="1">
-                <a:solidFill>
-                  <a:srgbClr val="3A3A3A"/>
-                </a:solidFill>
-                <a:latin typeface="Arial"/>
-                <a:ea typeface="Arial"/>
-                <a:cs typeface="Arial"/>
-              </a:rPr>
-              <a:t>usa</a:t>
-            </a:r>
-          </a:p>
-        </p:txBody>
-      </p:sp>
-      <p:sp>
-        <p:nvSpPr>
-          <p:cNvPr id="28" name="">
-            <a:extLst xmlns:a="http://schemas.openxmlformats.org/drawingml/2006/main">
-              <a:ext uri="{FF2B5EF4-FFF2-40B4-BE49-F238E27FC236}">
-                <a16:creationId xmlns:a16="http://schemas.microsoft.com/office/drawing/2014/main" id="{249B90B9-0730-426C-BC69-3DBD1291F1A5}"/>
-              </a:ext>
-            </a:extLst>
-          </p:cNvPr>
-          <p:cNvSpPr>
-            <a:spLocks xmlns:a="http://schemas.openxmlformats.org/drawingml/2006/main" noGrp="1"/>
-          </p:cNvSpPr>
-          <p:nvPr/>
-        </p:nvSpPr>
-        <p:spPr>
-          <a:xfrm xmlns:a="http://schemas.openxmlformats.org/drawingml/2006/main">
-            <a:off x="7762875" y="2447925"/>
             <a:ext cx="457200" cy="209550"/>
           </a:xfrm>
           <a:prstGeom xmlns:a="http://schemas.openxmlformats.org/drawingml/2006/main" prst="rect">
@@ -11491,6 +11335,219 @@
                 <a:cs typeface="Arial"/>
               </a:rPr>
               <a:t>El generador usa una definición manual que debe mantenerse sincronizada con el código.</a:t>
+            </a:r>
+          </a:p>
+        </p:txBody>
+      </p:sp>
+      <p:sp xmlns:a="http://schemas.openxmlformats.org/drawingml/2006/main">
+        <p:nvSpPr>
+          <p:cNvPr id="33" name="Rectangle 32"/>
+          <p:cNvSpPr/>
+          <p:nvPr/>
+        </p:nvSpPr>
+        <p:spPr>
+          <a:xfrm>
+            <a:off x="2295144" y="1920240"/>
+            <a:ext cx="18288" cy="155448"/>
+          </a:xfrm>
+          <a:prstGeom prst="rect">
+            <a:avLst/>
+          </a:prstGeom>
+          <a:solidFill>
+            <a:srgbClr val="555555"/>
+          </a:solidFill>
+          <a:ln>
+            <a:noFill/>
+          </a:ln>
+        </p:spPr>
+        <p:style>
+          <a:lnRef idx="1">
+            <a:schemeClr val="accent1"/>
+          </a:lnRef>
+          <a:fillRef idx="3">
+            <a:schemeClr val="accent1"/>
+          </a:fillRef>
+          <a:effectRef idx="2">
+            <a:schemeClr val="accent1"/>
+          </a:effectRef>
+          <a:fontRef idx="minor">
+            <a:schemeClr val="lt1"/>
+          </a:fontRef>
+        </p:style>
+        <p:txBody>
+          <a:bodyPr rtlCol="0" anchor="ctr"/>
+          <a:lstStyle/>
+          <a:p>
+            <a:pPr algn="ctr"/>
+          </a:p>
+        </p:txBody>
+      </p:sp>
+      <p:sp xmlns:a="http://schemas.openxmlformats.org/drawingml/2006/main">
+        <p:nvSpPr>
+          <p:cNvPr id="34" name="Rectangle 33"/>
+          <p:cNvSpPr/>
+          <p:nvPr/>
+        </p:nvSpPr>
+        <p:spPr>
+          <a:xfrm>
+            <a:off x="2295144" y="1920240"/>
+            <a:ext cx="5376672" cy="18288"/>
+          </a:xfrm>
+          <a:prstGeom prst="rect">
+            <a:avLst/>
+          </a:prstGeom>
+          <a:solidFill>
+            <a:srgbClr val="555555"/>
+          </a:solidFill>
+          <a:ln>
+            <a:noFill/>
+          </a:ln>
+        </p:spPr>
+        <p:style>
+          <a:lnRef idx="1">
+            <a:schemeClr val="accent1"/>
+          </a:lnRef>
+          <a:fillRef idx="3">
+            <a:schemeClr val="accent1"/>
+          </a:fillRef>
+          <a:effectRef idx="2">
+            <a:schemeClr val="accent1"/>
+          </a:effectRef>
+          <a:fontRef idx="minor">
+            <a:schemeClr val="lt1"/>
+          </a:fontRef>
+        </p:style>
+        <p:txBody>
+          <a:bodyPr rtlCol="0" anchor="ctr"/>
+          <a:lstStyle/>
+          <a:p>
+            <a:pPr algn="ctr"/>
+          </a:p>
+        </p:txBody>
+      </p:sp>
+      <p:sp xmlns:a="http://schemas.openxmlformats.org/drawingml/2006/main">
+        <p:nvSpPr>
+          <p:cNvPr id="35" name="Rectangle 34"/>
+          <p:cNvSpPr/>
+          <p:nvPr/>
+        </p:nvSpPr>
+        <p:spPr>
+          <a:xfrm>
+            <a:off x="8165592" y="1920240"/>
+            <a:ext cx="1719072" cy="18288"/>
+          </a:xfrm>
+          <a:prstGeom prst="rect">
+            <a:avLst/>
+          </a:prstGeom>
+          <a:solidFill>
+            <a:srgbClr val="555555"/>
+          </a:solidFill>
+          <a:ln>
+            <a:noFill/>
+          </a:ln>
+        </p:spPr>
+        <p:style>
+          <a:lnRef idx="1">
+            <a:schemeClr val="accent1"/>
+          </a:lnRef>
+          <a:fillRef idx="3">
+            <a:schemeClr val="accent1"/>
+          </a:fillRef>
+          <a:effectRef idx="2">
+            <a:schemeClr val="accent1"/>
+          </a:effectRef>
+          <a:fontRef idx="minor">
+            <a:schemeClr val="lt1"/>
+          </a:fontRef>
+        </p:style>
+        <p:txBody>
+          <a:bodyPr rtlCol="0" anchor="ctr"/>
+          <a:lstStyle/>
+          <a:p>
+            <a:pPr algn="ctr"/>
+          </a:p>
+        </p:txBody>
+      </p:sp>
+      <p:sp xmlns:a="http://schemas.openxmlformats.org/drawingml/2006/main">
+        <p:nvSpPr>
+          <p:cNvPr id="36" name="Rectangle 35"/>
+          <p:cNvSpPr/>
+          <p:nvPr/>
+        </p:nvSpPr>
+        <p:spPr>
+          <a:xfrm>
+            <a:off x="9866376" y="1920240"/>
+            <a:ext cx="18288" cy="155448"/>
+          </a:xfrm>
+          <a:prstGeom prst="rect">
+            <a:avLst/>
+          </a:prstGeom>
+          <a:solidFill>
+            <a:srgbClr val="555555"/>
+          </a:solidFill>
+          <a:ln>
+            <a:noFill/>
+          </a:ln>
+        </p:spPr>
+        <p:style>
+          <a:lnRef idx="1">
+            <a:schemeClr val="accent1"/>
+          </a:lnRef>
+          <a:fillRef idx="3">
+            <a:schemeClr val="accent1"/>
+          </a:fillRef>
+          <a:effectRef idx="2">
+            <a:schemeClr val="accent1"/>
+          </a:effectRef>
+          <a:fontRef idx="minor">
+            <a:schemeClr val="lt1"/>
+          </a:fontRef>
+        </p:style>
+        <p:txBody>
+          <a:bodyPr rtlCol="0" anchor="ctr"/>
+          <a:lstStyle/>
+          <a:p>
+            <a:pPr algn="ctr"/>
+          </a:p>
+        </p:txBody>
+      </p:sp>
+      <p:sp xmlns:a="http://schemas.openxmlformats.org/drawingml/2006/main">
+        <p:nvSpPr>
+          <p:cNvPr id="37" name="TextBox 36"/>
+          <p:cNvSpPr txBox="1"/>
+          <p:nvPr/>
+        </p:nvSpPr>
+        <p:spPr>
+          <a:xfrm>
+            <a:off x="7662672" y="1901952"/>
+            <a:ext cx="502920" cy="201168"/>
+          </a:xfrm>
+          <a:prstGeom prst="rect">
+            <a:avLst/>
+          </a:prstGeom>
+          <a:solidFill>
+            <a:srgbClr val="FFFFFF"/>
+          </a:solidFill>
+          <a:ln>
+            <a:noFill/>
+          </a:ln>
+        </p:spPr>
+        <p:txBody>
+          <a:bodyPr wrap="square" lIns="0" rIns="0" tIns="0" bIns="0">
+            <a:spAutoFit/>
+          </a:bodyPr>
+          <a:lstStyle/>
+          <a:p>
+            <a:pPr>
+              <a:defRPr sz="1000" b="0">
+                <a:solidFill>
+                  <a:srgbClr val="555555"/>
+                </a:solidFill>
+                <a:latin typeface="Arial"/>
+              </a:defRPr>
+            </a:pPr>
+            <a:r>
+              <a:t>usa</a:t>
             </a:r>
           </a:p>
         </p:txBody>
@@ -18692,1391 +18749,6 @@
       </p:sp>
       <p:sp>
         <p:nvSpPr>
-          <p:cNvPr id="4" name="risk-heading">
-            <a:extLst xmlns:a="http://schemas.openxmlformats.org/drawingml/2006/main">
-              <a:ext uri="{FF2B5EF4-FFF2-40B4-BE49-F238E27FC236}">
-                <a16:creationId xmlns:a16="http://schemas.microsoft.com/office/drawing/2014/main" id="{26A9D80B-53F3-451A-AFC4-0C279078109A}"/>
-              </a:ext>
-            </a:extLst>
-          </p:cNvPr>
-          <p:cNvSpPr>
-            <a:spLocks xmlns:a="http://schemas.openxmlformats.org/drawingml/2006/main" noGrp="1"/>
-          </p:cNvSpPr>
-          <p:nvPr/>
-        </p:nvSpPr>
-        <p:spPr>
-          <a:xfrm xmlns:a="http://schemas.openxmlformats.org/drawingml/2006/main">
-            <a:off x="781050" y="1409700"/>
-            <a:ext cx="4762500" cy="361950"/>
-          </a:xfrm>
-          <a:prstGeom xmlns:a="http://schemas.openxmlformats.org/drawingml/2006/main" prst="rect">
-            <a:avLst/>
-          </a:prstGeom>
-          <a:noFill xmlns:a="http://schemas.openxmlformats.org/drawingml/2006/main"/>
-          <a:ln xmlns:a="http://schemas.openxmlformats.org/drawingml/2006/main" w="0">
-            <a:noFill/>
-            <a:prstDash val="solid"/>
-          </a:ln>
-        </p:spPr>
-        <p:txBody>
-          <a:bodyPr xmlns:a="http://schemas.openxmlformats.org/drawingml/2006/main" lIns="0" tIns="0" rIns="0" bIns="0"/>
-          <a:lstStyle xmlns:a="http://schemas.openxmlformats.org/drawingml/2006/main">
-            <a:defPPr algn="l">
-              <a:defRPr sz="1875" b="1">
-                <a:solidFill>
-                  <a:srgbClr val="111111"/>
-                </a:solidFill>
-                <a:latin typeface="Arial"/>
-                <a:ea typeface="Arial"/>
-                <a:cs typeface="Arial"/>
-              </a:defRPr>
-            </a:defPPr>
-            <a:lvl1pPr algn="l">
-              <a:defRPr sz="1875" b="1">
-                <a:solidFill>
-                  <a:srgbClr val="111111"/>
-                </a:solidFill>
-                <a:latin typeface="Arial"/>
-                <a:ea typeface="Arial"/>
-                <a:cs typeface="Arial"/>
-              </a:defRPr>
-            </a:lvl1pPr>
-            <a:lvl2pPr algn="l">
-              <a:defRPr sz="1875" b="1">
-                <a:solidFill>
-                  <a:srgbClr val="111111"/>
-                </a:solidFill>
-                <a:latin typeface="Arial"/>
-                <a:ea typeface="Arial"/>
-                <a:cs typeface="Arial"/>
-              </a:defRPr>
-            </a:lvl2pPr>
-            <a:lvl3pPr algn="l">
-              <a:defRPr sz="1875" b="1">
-                <a:solidFill>
-                  <a:srgbClr val="111111"/>
-                </a:solidFill>
-                <a:latin typeface="Arial"/>
-                <a:ea typeface="Arial"/>
-                <a:cs typeface="Arial"/>
-              </a:defRPr>
-            </a:lvl3pPr>
-            <a:lvl4pPr algn="l">
-              <a:defRPr sz="1875" b="1">
-                <a:solidFill>
-                  <a:srgbClr val="111111"/>
-                </a:solidFill>
-                <a:latin typeface="Arial"/>
-                <a:ea typeface="Arial"/>
-                <a:cs typeface="Arial"/>
-              </a:defRPr>
-            </a:lvl4pPr>
-            <a:lvl5pPr algn="l">
-              <a:defRPr sz="1875" b="1">
-                <a:solidFill>
-                  <a:srgbClr val="111111"/>
-                </a:solidFill>
-                <a:latin typeface="Arial"/>
-                <a:ea typeface="Arial"/>
-                <a:cs typeface="Arial"/>
-              </a:defRPr>
-            </a:lvl5pPr>
-            <a:lvl6pPr algn="l">
-              <a:defRPr sz="1875" b="1">
-                <a:solidFill>
-                  <a:srgbClr val="111111"/>
-                </a:solidFill>
-                <a:latin typeface="Arial"/>
-                <a:ea typeface="Arial"/>
-                <a:cs typeface="Arial"/>
-              </a:defRPr>
-            </a:lvl6pPr>
-            <a:lvl7pPr algn="l">
-              <a:defRPr sz="1875" b="1">
-                <a:solidFill>
-                  <a:srgbClr val="111111"/>
-                </a:solidFill>
-                <a:latin typeface="Arial"/>
-                <a:ea typeface="Arial"/>
-                <a:cs typeface="Arial"/>
-              </a:defRPr>
-            </a:lvl7pPr>
-            <a:lvl8pPr algn="l">
-              <a:defRPr sz="1875" b="1">
-                <a:solidFill>
-                  <a:srgbClr val="111111"/>
-                </a:solidFill>
-                <a:latin typeface="Arial"/>
-                <a:ea typeface="Arial"/>
-                <a:cs typeface="Arial"/>
-              </a:defRPr>
-            </a:lvl8pPr>
-            <a:lvl9pPr algn="l">
-              <a:defRPr sz="1875" b="1">
-                <a:solidFill>
-                  <a:srgbClr val="111111"/>
-                </a:solidFill>
-                <a:latin typeface="Arial"/>
-                <a:ea typeface="Arial"/>
-                <a:cs typeface="Arial"/>
-              </a:defRPr>
-            </a:lvl9pPr>
-          </a:lstStyle>
-          <a:p xmlns:a="http://schemas.openxmlformats.org/drawingml/2006/main">
-            <a:pPr algn="l">
-              <a:defRPr sz="1875" b="1">
-                <a:solidFill>
-                  <a:srgbClr val="111111"/>
-                </a:solidFill>
-                <a:latin typeface="Arial"/>
-                <a:ea typeface="Arial"/>
-                <a:cs typeface="Arial"/>
-              </a:defRPr>
-            </a:pPr>
-            <a:r>
-              <a:rPr sz="1875" b="1">
-                <a:solidFill>
-                  <a:srgbClr val="111111"/>
-                </a:solidFill>
-                <a:latin typeface="Arial"/>
-                <a:ea typeface="Arial"/>
-                <a:cs typeface="Arial"/>
-              </a:rPr>
-              <a:t>Riesgos principales</a:t>
-            </a:r>
-          </a:p>
-        </p:txBody>
-      </p:sp>
-      <p:sp>
-        <p:nvSpPr>
-          <p:cNvPr id="5" name="risk-key">
-            <a:extLst xmlns:a="http://schemas.openxmlformats.org/drawingml/2006/main">
-              <a:ext uri="{FF2B5EF4-FFF2-40B4-BE49-F238E27FC236}">
-                <a16:creationId xmlns:a16="http://schemas.microsoft.com/office/drawing/2014/main" id="{5C48C859-0A85-47CC-A748-C5E9FAECE918}"/>
-              </a:ext>
-            </a:extLst>
-          </p:cNvPr>
-          <p:cNvSpPr>
-            <a:spLocks xmlns:a="http://schemas.openxmlformats.org/drawingml/2006/main" noGrp="1"/>
-          </p:cNvSpPr>
-          <p:nvPr/>
-        </p:nvSpPr>
-        <p:spPr>
-          <a:xfrm xmlns:a="http://schemas.openxmlformats.org/drawingml/2006/main">
-            <a:off x="781050" y="1752600"/>
-            <a:ext cx="4762500" cy="228600"/>
-          </a:xfrm>
-          <a:prstGeom xmlns:a="http://schemas.openxmlformats.org/drawingml/2006/main" prst="rect">
-            <a:avLst/>
-          </a:prstGeom>
-          <a:noFill xmlns:a="http://schemas.openxmlformats.org/drawingml/2006/main"/>
-          <a:ln xmlns:a="http://schemas.openxmlformats.org/drawingml/2006/main" w="0">
-            <a:noFill/>
-            <a:prstDash val="solid"/>
-          </a:ln>
-        </p:spPr>
-        <p:txBody>
-          <a:bodyPr xmlns:a="http://schemas.openxmlformats.org/drawingml/2006/main" lIns="0" tIns="0" rIns="0" bIns="0"/>
-          <a:lstStyle xmlns:a="http://schemas.openxmlformats.org/drawingml/2006/main">
-            <a:defPPr algn="l">
-              <a:defRPr sz="1200" b="0">
-                <a:solidFill>
-                  <a:srgbClr val="555555"/>
-                </a:solidFill>
-                <a:latin typeface="Arial"/>
-                <a:ea typeface="Arial"/>
-                <a:cs typeface="Arial"/>
-              </a:defRPr>
-            </a:defPPr>
-            <a:lvl1pPr algn="l">
-              <a:defRPr sz="1200" b="0">
-                <a:solidFill>
-                  <a:srgbClr val="555555"/>
-                </a:solidFill>
-                <a:latin typeface="Arial"/>
-                <a:ea typeface="Arial"/>
-                <a:cs typeface="Arial"/>
-              </a:defRPr>
-            </a:lvl1pPr>
-            <a:lvl2pPr algn="l">
-              <a:defRPr sz="1200" b="0">
-                <a:solidFill>
-                  <a:srgbClr val="555555"/>
-                </a:solidFill>
-                <a:latin typeface="Arial"/>
-                <a:ea typeface="Arial"/>
-                <a:cs typeface="Arial"/>
-              </a:defRPr>
-            </a:lvl2pPr>
-            <a:lvl3pPr algn="l">
-              <a:defRPr sz="1200" b="0">
-                <a:solidFill>
-                  <a:srgbClr val="555555"/>
-                </a:solidFill>
-                <a:latin typeface="Arial"/>
-                <a:ea typeface="Arial"/>
-                <a:cs typeface="Arial"/>
-              </a:defRPr>
-            </a:lvl3pPr>
-            <a:lvl4pPr algn="l">
-              <a:defRPr sz="1200" b="0">
-                <a:solidFill>
-                  <a:srgbClr val="555555"/>
-                </a:solidFill>
-                <a:latin typeface="Arial"/>
-                <a:ea typeface="Arial"/>
-                <a:cs typeface="Arial"/>
-              </a:defRPr>
-            </a:lvl4pPr>
-            <a:lvl5pPr algn="l">
-              <a:defRPr sz="1200" b="0">
-                <a:solidFill>
-                  <a:srgbClr val="555555"/>
-                </a:solidFill>
-                <a:latin typeface="Arial"/>
-                <a:ea typeface="Arial"/>
-                <a:cs typeface="Arial"/>
-              </a:defRPr>
-            </a:lvl5pPr>
-            <a:lvl6pPr algn="l">
-              <a:defRPr sz="1200" b="0">
-                <a:solidFill>
-                  <a:srgbClr val="555555"/>
-                </a:solidFill>
-                <a:latin typeface="Arial"/>
-                <a:ea typeface="Arial"/>
-                <a:cs typeface="Arial"/>
-              </a:defRPr>
-            </a:lvl6pPr>
-            <a:lvl7pPr algn="l">
-              <a:defRPr sz="1200" b="0">
-                <a:solidFill>
-                  <a:srgbClr val="555555"/>
-                </a:solidFill>
-                <a:latin typeface="Arial"/>
-                <a:ea typeface="Arial"/>
-                <a:cs typeface="Arial"/>
-              </a:defRPr>
-            </a:lvl7pPr>
-            <a:lvl8pPr algn="l">
-              <a:defRPr sz="1200" b="0">
-                <a:solidFill>
-                  <a:srgbClr val="555555"/>
-                </a:solidFill>
-                <a:latin typeface="Arial"/>
-                <a:ea typeface="Arial"/>
-                <a:cs typeface="Arial"/>
-              </a:defRPr>
-            </a:lvl8pPr>
-            <a:lvl9pPr algn="l">
-              <a:defRPr sz="1200" b="0">
-                <a:solidFill>
-                  <a:srgbClr val="555555"/>
-                </a:solidFill>
-                <a:latin typeface="Arial"/>
-                <a:ea typeface="Arial"/>
-                <a:cs typeface="Arial"/>
-              </a:defRPr>
-            </a:lvl9pPr>
-          </a:lstStyle>
-          <a:p xmlns:a="http://schemas.openxmlformats.org/drawingml/2006/main">
-            <a:pPr algn="l">
-              <a:defRPr sz="1200" b="0">
-                <a:solidFill>
-                  <a:srgbClr val="555555"/>
-                </a:solidFill>
-                <a:latin typeface="Arial"/>
-                <a:ea typeface="Arial"/>
-                <a:cs typeface="Arial"/>
-              </a:defRPr>
-            </a:pPr>
-            <a:r>
-              <a:rPr sz="1200" b="0">
-                <a:solidFill>
-                  <a:srgbClr val="555555"/>
-                </a:solidFill>
-                <a:latin typeface="Arial"/>
-                <a:ea typeface="Arial"/>
-                <a:cs typeface="Arial"/>
-              </a:rPr>
-              <a:t>P = probabilidad · I = impacto</a:t>
-            </a:r>
-          </a:p>
-        </p:txBody>
-      </p:sp>
-      <p:sp>
-        <p:nvSpPr>
-          <p:cNvPr id="6" name="risk-list">
-            <a:extLst xmlns:a="http://schemas.openxmlformats.org/drawingml/2006/main">
-              <a:ext uri="{FF2B5EF4-FFF2-40B4-BE49-F238E27FC236}">
-                <a16:creationId xmlns:a16="http://schemas.microsoft.com/office/drawing/2014/main" id="{7D08D77A-EFB8-42F1-A6E5-2CDAE532FBB6}"/>
-              </a:ext>
-            </a:extLst>
-          </p:cNvPr>
-          <p:cNvSpPr>
-            <a:spLocks xmlns:a="http://schemas.openxmlformats.org/drawingml/2006/main" noGrp="1"/>
-          </p:cNvSpPr>
-          <p:nvPr/>
-        </p:nvSpPr>
-        <p:spPr>
-          <a:xfrm xmlns:a="http://schemas.openxmlformats.org/drawingml/2006/main">
-            <a:off x="781050" y="2057400"/>
-            <a:ext cx="4810125" cy="3333750"/>
-          </a:xfrm>
-          <a:prstGeom xmlns:a="http://schemas.openxmlformats.org/drawingml/2006/main" prst="rect">
-            <a:avLst/>
-          </a:prstGeom>
-          <a:noFill xmlns:a="http://schemas.openxmlformats.org/drawingml/2006/main"/>
-          <a:ln xmlns:a="http://schemas.openxmlformats.org/drawingml/2006/main" w="0">
-            <a:noFill/>
-            <a:prstDash val="solid"/>
-          </a:ln>
-        </p:spPr>
-        <p:txBody>
-          <a:bodyPr xmlns:a="http://schemas.openxmlformats.org/drawingml/2006/main" lIns="0" tIns="0" rIns="0" bIns="0"/>
-          <a:lstStyle xmlns:a="http://schemas.openxmlformats.org/drawingml/2006/main">
-            <a:defPPr algn="l">
-              <a:defRPr sz="1350" b="0">
-                <a:solidFill>
-                  <a:srgbClr val="222222"/>
-                </a:solidFill>
-                <a:latin typeface="Arial"/>
-                <a:ea typeface="Arial"/>
-                <a:cs typeface="Arial"/>
-              </a:defRPr>
-            </a:defPPr>
-            <a:lvl1pPr algn="l">
-              <a:defRPr sz="1350" b="0">
-                <a:solidFill>
-                  <a:srgbClr val="222222"/>
-                </a:solidFill>
-                <a:latin typeface="Arial"/>
-                <a:ea typeface="Arial"/>
-                <a:cs typeface="Arial"/>
-              </a:defRPr>
-            </a:lvl1pPr>
-            <a:lvl2pPr algn="l">
-              <a:defRPr sz="1350" b="0">
-                <a:solidFill>
-                  <a:srgbClr val="222222"/>
-                </a:solidFill>
-                <a:latin typeface="Arial"/>
-                <a:ea typeface="Arial"/>
-                <a:cs typeface="Arial"/>
-              </a:defRPr>
-            </a:lvl2pPr>
-            <a:lvl3pPr algn="l">
-              <a:defRPr sz="1350" b="0">
-                <a:solidFill>
-                  <a:srgbClr val="222222"/>
-                </a:solidFill>
-                <a:latin typeface="Arial"/>
-                <a:ea typeface="Arial"/>
-                <a:cs typeface="Arial"/>
-              </a:defRPr>
-            </a:lvl3pPr>
-            <a:lvl4pPr algn="l">
-              <a:defRPr sz="1350" b="0">
-                <a:solidFill>
-                  <a:srgbClr val="222222"/>
-                </a:solidFill>
-                <a:latin typeface="Arial"/>
-                <a:ea typeface="Arial"/>
-                <a:cs typeface="Arial"/>
-              </a:defRPr>
-            </a:lvl4pPr>
-            <a:lvl5pPr algn="l">
-              <a:defRPr sz="1350" b="0">
-                <a:solidFill>
-                  <a:srgbClr val="222222"/>
-                </a:solidFill>
-                <a:latin typeface="Arial"/>
-                <a:ea typeface="Arial"/>
-                <a:cs typeface="Arial"/>
-              </a:defRPr>
-            </a:lvl5pPr>
-            <a:lvl6pPr algn="l">
-              <a:defRPr sz="1350" b="0">
-                <a:solidFill>
-                  <a:srgbClr val="222222"/>
-                </a:solidFill>
-                <a:latin typeface="Arial"/>
-                <a:ea typeface="Arial"/>
-                <a:cs typeface="Arial"/>
-              </a:defRPr>
-            </a:lvl6pPr>
-            <a:lvl7pPr algn="l">
-              <a:defRPr sz="1350" b="0">
-                <a:solidFill>
-                  <a:srgbClr val="222222"/>
-                </a:solidFill>
-                <a:latin typeface="Arial"/>
-                <a:ea typeface="Arial"/>
-                <a:cs typeface="Arial"/>
-              </a:defRPr>
-            </a:lvl7pPr>
-            <a:lvl8pPr algn="l">
-              <a:defRPr sz="1350" b="0">
-                <a:solidFill>
-                  <a:srgbClr val="222222"/>
-                </a:solidFill>
-                <a:latin typeface="Arial"/>
-                <a:ea typeface="Arial"/>
-                <a:cs typeface="Arial"/>
-              </a:defRPr>
-            </a:lvl8pPr>
-            <a:lvl9pPr algn="l">
-              <a:defRPr sz="1350" b="0">
-                <a:solidFill>
-                  <a:srgbClr val="222222"/>
-                </a:solidFill>
-                <a:latin typeface="Arial"/>
-                <a:ea typeface="Arial"/>
-                <a:cs typeface="Arial"/>
-              </a:defRPr>
-            </a:lvl9pPr>
-          </a:lstStyle>
-          <a:p xmlns:a="http://schemas.openxmlformats.org/drawingml/2006/main">
-            <a:pPr algn="l">
-              <a:defRPr sz="1350" b="0">
-                <a:solidFill>
-                  <a:srgbClr val="222222"/>
-                </a:solidFill>
-                <a:latin typeface="Arial"/>
-                <a:ea typeface="Arial"/>
-                <a:cs typeface="Arial"/>
-              </a:defRPr>
-            </a:pPr>
-            <a:r>
-              <a:rPr sz="1350" b="0">
-                <a:solidFill>
-                  <a:srgbClr val="222222"/>
-                </a:solidFill>
-                <a:latin typeface="Arial"/>
-                <a:ea typeface="Arial"/>
-                <a:cs typeface="Arial"/>
-              </a:rPr>
-              <a:t>Reglas incorrectas — P media / I alta: pruebas por requisito.</a:t>
-            </a:r>
-          </a:p>
-          <a:p xmlns:a="http://schemas.openxmlformats.org/drawingml/2006/main">
-            <a:r>
-              <a:t/>
-            </a:r>
-          </a:p>
-          <a:p xmlns:a="http://schemas.openxmlformats.org/drawingml/2006/main">
-            <a:pPr algn="l">
-              <a:defRPr sz="1350" b="0">
-                <a:solidFill>
-                  <a:srgbClr val="222222"/>
-                </a:solidFill>
-                <a:latin typeface="Arial"/>
-                <a:ea typeface="Arial"/>
-                <a:cs typeface="Arial"/>
-              </a:defRPr>
-            </a:pPr>
-            <a:r>
-              <a:rPr sz="1350" b="0">
-                <a:solidFill>
-                  <a:srgbClr val="222222"/>
-                </a:solidFill>
-                <a:latin typeface="Arial"/>
-                <a:ea typeface="Arial"/>
-                <a:cs typeface="Arial"/>
-              </a:rPr>
-              <a:t>Tests débiles — P media / I alta: revisar las aserciones.</a:t>
-            </a:r>
-          </a:p>
-          <a:p xmlns:a="http://schemas.openxmlformats.org/drawingml/2006/main">
-            <a:r>
-              <a:t/>
-            </a:r>
-          </a:p>
-          <a:p xmlns:a="http://schemas.openxmlformats.org/drawingml/2006/main">
-            <a:pPr algn="l">
-              <a:defRPr sz="1350" b="0">
-                <a:solidFill>
-                  <a:srgbClr val="222222"/>
-                </a:solidFill>
-                <a:latin typeface="Arial"/>
-                <a:ea typeface="Arial"/>
-                <a:cs typeface="Arial"/>
-              </a:defRPr>
-            </a:pPr>
-            <a:r>
-              <a:rPr sz="1350" b="0">
-                <a:solidFill>
-                  <a:srgbClr val="222222"/>
-                </a:solidFill>
-                <a:latin typeface="Arial"/>
-                <a:ea typeface="Arial"/>
-                <a:cs typeface="Arial"/>
-              </a:rPr>
-              <a:t>Pérdida de código — P baja / I alta: repositorio remoto y suite final.</a:t>
-            </a:r>
-          </a:p>
-          <a:p xmlns:a="http://schemas.openxmlformats.org/drawingml/2006/main">
-            <a:r>
-              <a:t/>
-            </a:r>
-          </a:p>
-          <a:p xmlns:a="http://schemas.openxmlformats.org/drawingml/2006/main">
-            <a:pPr algn="l">
-              <a:defRPr sz="1350" b="0">
-                <a:solidFill>
-                  <a:srgbClr val="222222"/>
-                </a:solidFill>
-                <a:latin typeface="Arial"/>
-                <a:ea typeface="Arial"/>
-                <a:cs typeface="Arial"/>
-              </a:defRPr>
-            </a:pPr>
-            <a:r>
-              <a:rPr sz="1350" b="0">
-                <a:solidFill>
-                  <a:srgbClr val="222222"/>
-                </a:solidFill>
-                <a:latin typeface="Arial"/>
-                <a:ea typeface="Arial"/>
-                <a:cs typeface="Arial"/>
-              </a:rPr>
-              <a:t>Conocimiento concentrado — P media / I media: revisión compartida.</a:t>
-            </a:r>
-          </a:p>
-          <a:p xmlns:a="http://schemas.openxmlformats.org/drawingml/2006/main">
-            <a:r>
-              <a:t/>
-            </a:r>
-          </a:p>
-          <a:p xmlns:a="http://schemas.openxmlformats.org/drawingml/2006/main">
-            <a:pPr algn="l">
-              <a:defRPr sz="1350" b="0">
-                <a:solidFill>
-                  <a:srgbClr val="222222"/>
-                </a:solidFill>
-                <a:latin typeface="Arial"/>
-                <a:ea typeface="Arial"/>
-                <a:cs typeface="Arial"/>
-              </a:defRPr>
-            </a:pPr>
-            <a:r>
-              <a:rPr sz="1350" b="0">
-                <a:solidFill>
-                  <a:srgbClr val="222222"/>
-                </a:solidFill>
-                <a:latin typeface="Arial"/>
-                <a:ea typeface="Arial"/>
-                <a:cs typeface="Arial"/>
-              </a:rPr>
-              <a:t>Clave expuesta — P baja hoy / I alta: no integrar IA.</a:t>
-            </a:r>
-          </a:p>
-        </p:txBody>
-      </p:sp>
-      <p:sp>
-        <p:nvSpPr>
-          <p:cNvPr id="7" name="column-divider">
-            <a:extLst xmlns:a="http://schemas.openxmlformats.org/drawingml/2006/main">
-              <a:ext uri="{FF2B5EF4-FFF2-40B4-BE49-F238E27FC236}">
-                <a16:creationId xmlns:a16="http://schemas.microsoft.com/office/drawing/2014/main" id="{283EDB14-B899-4058-8233-3E75DE3B2BF9}"/>
-              </a:ext>
-            </a:extLst>
-          </p:cNvPr>
-          <p:cNvSpPr>
-            <a:spLocks xmlns:a="http://schemas.openxmlformats.org/drawingml/2006/main" noGrp="1"/>
-          </p:cNvSpPr>
-          <p:nvPr/>
-        </p:nvSpPr>
-        <p:spPr>
-          <a:xfrm xmlns:a="http://schemas.openxmlformats.org/drawingml/2006/main">
-            <a:off x="5953125" y="1409700"/>
-            <a:ext cx="14288" cy="4000500"/>
-          </a:xfrm>
-          <a:prstGeom xmlns:a="http://schemas.openxmlformats.org/drawingml/2006/main" prst="rect">
-            <a:avLst/>
-          </a:prstGeom>
-          <a:solidFill xmlns:a="http://schemas.openxmlformats.org/drawingml/2006/main">
-            <a:srgbClr val="B8C2C6"/>
-          </a:solidFill>
-          <a:ln xmlns:a="http://schemas.openxmlformats.org/drawingml/2006/main" w="0">
-            <a:noFill/>
-            <a:prstDash val="solid"/>
-          </a:ln>
-        </p:spPr>
-      </p:sp>
-      <p:sp>
-        <p:nvSpPr>
-          <p:cNvPr id="8" name="metrics-heading">
-            <a:extLst xmlns:a="http://schemas.openxmlformats.org/drawingml/2006/main">
-              <a:ext uri="{FF2B5EF4-FFF2-40B4-BE49-F238E27FC236}">
-                <a16:creationId xmlns:a16="http://schemas.microsoft.com/office/drawing/2014/main" id="{19626D26-2A00-46D4-B355-C9ED56911C19}"/>
-              </a:ext>
-            </a:extLst>
-          </p:cNvPr>
-          <p:cNvSpPr>
-            <a:spLocks xmlns:a="http://schemas.openxmlformats.org/drawingml/2006/main" noGrp="1"/>
-          </p:cNvSpPr>
-          <p:nvPr/>
-        </p:nvSpPr>
-        <p:spPr>
-          <a:xfrm xmlns:a="http://schemas.openxmlformats.org/drawingml/2006/main">
-            <a:off x="6334125" y="1409700"/>
-            <a:ext cx="5000625" cy="361950"/>
-          </a:xfrm>
-          <a:prstGeom xmlns:a="http://schemas.openxmlformats.org/drawingml/2006/main" prst="rect">
-            <a:avLst/>
-          </a:prstGeom>
-          <a:noFill xmlns:a="http://schemas.openxmlformats.org/drawingml/2006/main"/>
-          <a:ln xmlns:a="http://schemas.openxmlformats.org/drawingml/2006/main" w="0">
-            <a:noFill/>
-            <a:prstDash val="solid"/>
-          </a:ln>
-        </p:spPr>
-        <p:txBody>
-          <a:bodyPr xmlns:a="http://schemas.openxmlformats.org/drawingml/2006/main" lIns="0" tIns="0" rIns="0" bIns="0"/>
-          <a:lstStyle xmlns:a="http://schemas.openxmlformats.org/drawingml/2006/main">
-            <a:defPPr algn="l">
-              <a:defRPr sz="1875" b="1">
-                <a:solidFill>
-                  <a:srgbClr val="111111"/>
-                </a:solidFill>
-                <a:latin typeface="Arial"/>
-                <a:ea typeface="Arial"/>
-                <a:cs typeface="Arial"/>
-              </a:defRPr>
-            </a:defPPr>
-            <a:lvl1pPr algn="l">
-              <a:defRPr sz="1875" b="1">
-                <a:solidFill>
-                  <a:srgbClr val="111111"/>
-                </a:solidFill>
-                <a:latin typeface="Arial"/>
-                <a:ea typeface="Arial"/>
-                <a:cs typeface="Arial"/>
-              </a:defRPr>
-            </a:lvl1pPr>
-            <a:lvl2pPr algn="l">
-              <a:defRPr sz="1875" b="1">
-                <a:solidFill>
-                  <a:srgbClr val="111111"/>
-                </a:solidFill>
-                <a:latin typeface="Arial"/>
-                <a:ea typeface="Arial"/>
-                <a:cs typeface="Arial"/>
-              </a:defRPr>
-            </a:lvl2pPr>
-            <a:lvl3pPr algn="l">
-              <a:defRPr sz="1875" b="1">
-                <a:solidFill>
-                  <a:srgbClr val="111111"/>
-                </a:solidFill>
-                <a:latin typeface="Arial"/>
-                <a:ea typeface="Arial"/>
-                <a:cs typeface="Arial"/>
-              </a:defRPr>
-            </a:lvl3pPr>
-            <a:lvl4pPr algn="l">
-              <a:defRPr sz="1875" b="1">
-                <a:solidFill>
-                  <a:srgbClr val="111111"/>
-                </a:solidFill>
-                <a:latin typeface="Arial"/>
-                <a:ea typeface="Arial"/>
-                <a:cs typeface="Arial"/>
-              </a:defRPr>
-            </a:lvl4pPr>
-            <a:lvl5pPr algn="l">
-              <a:defRPr sz="1875" b="1">
-                <a:solidFill>
-                  <a:srgbClr val="111111"/>
-                </a:solidFill>
-                <a:latin typeface="Arial"/>
-                <a:ea typeface="Arial"/>
-                <a:cs typeface="Arial"/>
-              </a:defRPr>
-            </a:lvl5pPr>
-            <a:lvl6pPr algn="l">
-              <a:defRPr sz="1875" b="1">
-                <a:solidFill>
-                  <a:srgbClr val="111111"/>
-                </a:solidFill>
-                <a:latin typeface="Arial"/>
-                <a:ea typeface="Arial"/>
-                <a:cs typeface="Arial"/>
-              </a:defRPr>
-            </a:lvl6pPr>
-            <a:lvl7pPr algn="l">
-              <a:defRPr sz="1875" b="1">
-                <a:solidFill>
-                  <a:srgbClr val="111111"/>
-                </a:solidFill>
-                <a:latin typeface="Arial"/>
-                <a:ea typeface="Arial"/>
-                <a:cs typeface="Arial"/>
-              </a:defRPr>
-            </a:lvl7pPr>
-            <a:lvl8pPr algn="l">
-              <a:defRPr sz="1875" b="1">
-                <a:solidFill>
-                  <a:srgbClr val="111111"/>
-                </a:solidFill>
-                <a:latin typeface="Arial"/>
-                <a:ea typeface="Arial"/>
-                <a:cs typeface="Arial"/>
-              </a:defRPr>
-            </a:lvl8pPr>
-            <a:lvl9pPr algn="l">
-              <a:defRPr sz="1875" b="1">
-                <a:solidFill>
-                  <a:srgbClr val="111111"/>
-                </a:solidFill>
-                <a:latin typeface="Arial"/>
-                <a:ea typeface="Arial"/>
-                <a:cs typeface="Arial"/>
-              </a:defRPr>
-            </a:lvl9pPr>
-          </a:lstStyle>
-          <a:p xmlns:a="http://schemas.openxmlformats.org/drawingml/2006/main">
-            <a:pPr algn="l">
-              <a:defRPr sz="1875" b="1">
-                <a:solidFill>
-                  <a:srgbClr val="111111"/>
-                </a:solidFill>
-                <a:latin typeface="Arial"/>
-                <a:ea typeface="Arial"/>
-                <a:cs typeface="Arial"/>
-              </a:defRPr>
-            </a:pPr>
-            <a:r>
-              <a:rPr sz="1875" b="1">
-                <a:solidFill>
-                  <a:srgbClr val="111111"/>
-                </a:solidFill>
-                <a:latin typeface="Arial"/>
-                <a:ea typeface="Arial"/>
-                <a:cs typeface="Arial"/>
-              </a:rPr>
-              <a:t>Meta e indicadores</a:t>
-            </a:r>
-          </a:p>
-        </p:txBody>
-      </p:sp>
-      <p:sp>
-        <p:nvSpPr>
-          <p:cNvPr id="9" name="goal">
-            <a:extLst xmlns:a="http://schemas.openxmlformats.org/drawingml/2006/main">
-              <a:ext uri="{FF2B5EF4-FFF2-40B4-BE49-F238E27FC236}">
-                <a16:creationId xmlns:a16="http://schemas.microsoft.com/office/drawing/2014/main" id="{28615166-F47A-4FDE-8CFA-2D3CDBF02714}"/>
-              </a:ext>
-            </a:extLst>
-          </p:cNvPr>
-          <p:cNvSpPr>
-            <a:spLocks xmlns:a="http://schemas.openxmlformats.org/drawingml/2006/main" noGrp="1"/>
-          </p:cNvSpPr>
-          <p:nvPr/>
-        </p:nvSpPr>
-        <p:spPr>
-          <a:xfrm xmlns:a="http://schemas.openxmlformats.org/drawingml/2006/main">
-            <a:off x="6334125" y="1885950"/>
-            <a:ext cx="5000625" cy="495300"/>
-          </a:xfrm>
-          <a:prstGeom xmlns:a="http://schemas.openxmlformats.org/drawingml/2006/main" prst="rect">
-            <a:avLst/>
-          </a:prstGeom>
-          <a:noFill xmlns:a="http://schemas.openxmlformats.org/drawingml/2006/main"/>
-          <a:ln xmlns:a="http://schemas.openxmlformats.org/drawingml/2006/main" w="0">
-            <a:noFill/>
-            <a:prstDash val="solid"/>
-          </a:ln>
-        </p:spPr>
-        <p:txBody>
-          <a:bodyPr xmlns:a="http://schemas.openxmlformats.org/drawingml/2006/main" lIns="0" tIns="0" rIns="0" bIns="0"/>
-          <a:lstStyle xmlns:a="http://schemas.openxmlformats.org/drawingml/2006/main">
-            <a:defPPr algn="l">
-              <a:defRPr sz="1425" b="1">
-                <a:solidFill>
-                  <a:srgbClr val="222222"/>
-                </a:solidFill>
-                <a:latin typeface="Arial"/>
-                <a:ea typeface="Arial"/>
-                <a:cs typeface="Arial"/>
-              </a:defRPr>
-            </a:defPPr>
-            <a:lvl1pPr algn="l">
-              <a:defRPr sz="1425" b="1">
-                <a:solidFill>
-                  <a:srgbClr val="222222"/>
-                </a:solidFill>
-                <a:latin typeface="Arial"/>
-                <a:ea typeface="Arial"/>
-                <a:cs typeface="Arial"/>
-              </a:defRPr>
-            </a:lvl1pPr>
-            <a:lvl2pPr algn="l">
-              <a:defRPr sz="1425" b="1">
-                <a:solidFill>
-                  <a:srgbClr val="222222"/>
-                </a:solidFill>
-                <a:latin typeface="Arial"/>
-                <a:ea typeface="Arial"/>
-                <a:cs typeface="Arial"/>
-              </a:defRPr>
-            </a:lvl2pPr>
-            <a:lvl3pPr algn="l">
-              <a:defRPr sz="1425" b="1">
-                <a:solidFill>
-                  <a:srgbClr val="222222"/>
-                </a:solidFill>
-                <a:latin typeface="Arial"/>
-                <a:ea typeface="Arial"/>
-                <a:cs typeface="Arial"/>
-              </a:defRPr>
-            </a:lvl3pPr>
-            <a:lvl4pPr algn="l">
-              <a:defRPr sz="1425" b="1">
-                <a:solidFill>
-                  <a:srgbClr val="222222"/>
-                </a:solidFill>
-                <a:latin typeface="Arial"/>
-                <a:ea typeface="Arial"/>
-                <a:cs typeface="Arial"/>
-              </a:defRPr>
-            </a:lvl4pPr>
-            <a:lvl5pPr algn="l">
-              <a:defRPr sz="1425" b="1">
-                <a:solidFill>
-                  <a:srgbClr val="222222"/>
-                </a:solidFill>
-                <a:latin typeface="Arial"/>
-                <a:ea typeface="Arial"/>
-                <a:cs typeface="Arial"/>
-              </a:defRPr>
-            </a:lvl5pPr>
-            <a:lvl6pPr algn="l">
-              <a:defRPr sz="1425" b="1">
-                <a:solidFill>
-                  <a:srgbClr val="222222"/>
-                </a:solidFill>
-                <a:latin typeface="Arial"/>
-                <a:ea typeface="Arial"/>
-                <a:cs typeface="Arial"/>
-              </a:defRPr>
-            </a:lvl6pPr>
-            <a:lvl7pPr algn="l">
-              <a:defRPr sz="1425" b="1">
-                <a:solidFill>
-                  <a:srgbClr val="222222"/>
-                </a:solidFill>
-                <a:latin typeface="Arial"/>
-                <a:ea typeface="Arial"/>
-                <a:cs typeface="Arial"/>
-              </a:defRPr>
-            </a:lvl7pPr>
-            <a:lvl8pPr algn="l">
-              <a:defRPr sz="1425" b="1">
-                <a:solidFill>
-                  <a:srgbClr val="222222"/>
-                </a:solidFill>
-                <a:latin typeface="Arial"/>
-                <a:ea typeface="Arial"/>
-                <a:cs typeface="Arial"/>
-              </a:defRPr>
-            </a:lvl8pPr>
-            <a:lvl9pPr algn="l">
-              <a:defRPr sz="1425" b="1">
-                <a:solidFill>
-                  <a:srgbClr val="222222"/>
-                </a:solidFill>
-                <a:latin typeface="Arial"/>
-                <a:ea typeface="Arial"/>
-                <a:cs typeface="Arial"/>
-              </a:defRPr>
-            </a:lvl9pPr>
-          </a:lstStyle>
-          <a:p xmlns:a="http://schemas.openxmlformats.org/drawingml/2006/main">
-            <a:pPr algn="l">
-              <a:defRPr sz="1425" b="1">
-                <a:solidFill>
-                  <a:srgbClr val="222222"/>
-                </a:solidFill>
-                <a:latin typeface="Arial"/>
-                <a:ea typeface="Arial"/>
-                <a:cs typeface="Arial"/>
-              </a:defRPr>
-            </a:pPr>
-            <a:r>
-              <a:rPr sz="1425" b="1">
-                <a:solidFill>
-                  <a:srgbClr val="222222"/>
-                </a:solidFill>
-                <a:latin typeface="Arial"/>
-                <a:ea typeface="Arial"/>
-                <a:cs typeface="Arial"/>
-              </a:rPr>
-              <a:t>Meta: cumplir los requisitos obligatorios y poder verificarlo.</a:t>
-            </a:r>
-          </a:p>
-        </p:txBody>
-      </p:sp>
-      <p:sp>
-        <p:nvSpPr>
-          <p:cNvPr id="10" name="metrics-list">
-            <a:extLst xmlns:a="http://schemas.openxmlformats.org/drawingml/2006/main">
-              <a:ext uri="{FF2B5EF4-FFF2-40B4-BE49-F238E27FC236}">
-                <a16:creationId xmlns:a16="http://schemas.microsoft.com/office/drawing/2014/main" id="{528CCCC9-86E5-4FC6-890C-163E84AA0E91}"/>
-              </a:ext>
-            </a:extLst>
-          </p:cNvPr>
-          <p:cNvSpPr>
-            <a:spLocks xmlns:a="http://schemas.openxmlformats.org/drawingml/2006/main" noGrp="1"/>
-          </p:cNvSpPr>
-          <p:nvPr/>
-        </p:nvSpPr>
-        <p:spPr>
-          <a:xfrm xmlns:a="http://schemas.openxmlformats.org/drawingml/2006/main">
-            <a:off x="6334125" y="2428875"/>
-            <a:ext cx="5000625" cy="3095625"/>
-          </a:xfrm>
-          <a:prstGeom xmlns:a="http://schemas.openxmlformats.org/drawingml/2006/main" prst="rect">
-            <a:avLst/>
-          </a:prstGeom>
-          <a:noFill xmlns:a="http://schemas.openxmlformats.org/drawingml/2006/main"/>
-          <a:ln xmlns:a="http://schemas.openxmlformats.org/drawingml/2006/main" w="0">
-            <a:noFill/>
-            <a:prstDash val="solid"/>
-          </a:ln>
-        </p:spPr>
-        <p:txBody>
-          <a:bodyPr xmlns:a="http://schemas.openxmlformats.org/drawingml/2006/main" lIns="0" tIns="0" rIns="0" bIns="0"/>
-          <a:lstStyle xmlns:a="http://schemas.openxmlformats.org/drawingml/2006/main">
-            <a:defPPr algn="l">
-              <a:defRPr sz="1275" b="0">
-                <a:solidFill>
-                  <a:srgbClr val="222222"/>
-                </a:solidFill>
-                <a:latin typeface="Arial"/>
-                <a:ea typeface="Arial"/>
-                <a:cs typeface="Arial"/>
-              </a:defRPr>
-            </a:defPPr>
-            <a:lvl1pPr algn="l">
-              <a:defRPr sz="1275" b="0">
-                <a:solidFill>
-                  <a:srgbClr val="222222"/>
-                </a:solidFill>
-                <a:latin typeface="Arial"/>
-                <a:ea typeface="Arial"/>
-                <a:cs typeface="Arial"/>
-              </a:defRPr>
-            </a:lvl1pPr>
-            <a:lvl2pPr algn="l">
-              <a:defRPr sz="1275" b="0">
-                <a:solidFill>
-                  <a:srgbClr val="222222"/>
-                </a:solidFill>
-                <a:latin typeface="Arial"/>
-                <a:ea typeface="Arial"/>
-                <a:cs typeface="Arial"/>
-              </a:defRPr>
-            </a:lvl2pPr>
-            <a:lvl3pPr algn="l">
-              <a:defRPr sz="1275" b="0">
-                <a:solidFill>
-                  <a:srgbClr val="222222"/>
-                </a:solidFill>
-                <a:latin typeface="Arial"/>
-                <a:ea typeface="Arial"/>
-                <a:cs typeface="Arial"/>
-              </a:defRPr>
-            </a:lvl3pPr>
-            <a:lvl4pPr algn="l">
-              <a:defRPr sz="1275" b="0">
-                <a:solidFill>
-                  <a:srgbClr val="222222"/>
-                </a:solidFill>
-                <a:latin typeface="Arial"/>
-                <a:ea typeface="Arial"/>
-                <a:cs typeface="Arial"/>
-              </a:defRPr>
-            </a:lvl4pPr>
-            <a:lvl5pPr algn="l">
-              <a:defRPr sz="1275" b="0">
-                <a:solidFill>
-                  <a:srgbClr val="222222"/>
-                </a:solidFill>
-                <a:latin typeface="Arial"/>
-                <a:ea typeface="Arial"/>
-                <a:cs typeface="Arial"/>
-              </a:defRPr>
-            </a:lvl5pPr>
-            <a:lvl6pPr algn="l">
-              <a:defRPr sz="1275" b="0">
-                <a:solidFill>
-                  <a:srgbClr val="222222"/>
-                </a:solidFill>
-                <a:latin typeface="Arial"/>
-                <a:ea typeface="Arial"/>
-                <a:cs typeface="Arial"/>
-              </a:defRPr>
-            </a:lvl6pPr>
-            <a:lvl7pPr algn="l">
-              <a:defRPr sz="1275" b="0">
-                <a:solidFill>
-                  <a:srgbClr val="222222"/>
-                </a:solidFill>
-                <a:latin typeface="Arial"/>
-                <a:ea typeface="Arial"/>
-                <a:cs typeface="Arial"/>
-              </a:defRPr>
-            </a:lvl7pPr>
-            <a:lvl8pPr algn="l">
-              <a:defRPr sz="1275" b="0">
-                <a:solidFill>
-                  <a:srgbClr val="222222"/>
-                </a:solidFill>
-                <a:latin typeface="Arial"/>
-                <a:ea typeface="Arial"/>
-                <a:cs typeface="Arial"/>
-              </a:defRPr>
-            </a:lvl8pPr>
-            <a:lvl9pPr algn="l">
-              <a:defRPr sz="1275" b="0">
-                <a:solidFill>
-                  <a:srgbClr val="222222"/>
-                </a:solidFill>
-                <a:latin typeface="Arial"/>
-                <a:ea typeface="Arial"/>
-                <a:cs typeface="Arial"/>
-              </a:defRPr>
-            </a:lvl9pPr>
-          </a:lstStyle>
-          <a:p xmlns:a="http://schemas.openxmlformats.org/drawingml/2006/main">
-            <a:pPr algn="l">
-              <a:defRPr sz="1275" b="0">
-                <a:solidFill>
-                  <a:srgbClr val="222222"/>
-                </a:solidFill>
-                <a:latin typeface="Arial"/>
-                <a:ea typeface="Arial"/>
-                <a:cs typeface="Arial"/>
-              </a:defRPr>
-            </a:pPr>
-            <a:r>
-              <a:rPr sz="1275" b="0">
-                <a:solidFill>
-                  <a:srgbClr val="222222"/>
-                </a:solidFill>
-                <a:latin typeface="Arial"/>
-                <a:ea typeface="Arial"/>
-                <a:cs typeface="Arial"/>
-              </a:rPr>
-              <a:t>1. Cobertura: requisitos con test significativo / requisitos obligatorios × 100.</a:t>
-            </a:r>
-          </a:p>
-          <a:p xmlns:a="http://schemas.openxmlformats.org/drawingml/2006/main">
-            <a:r>
-              <a:t/>
-            </a:r>
-          </a:p>
-          <a:p xmlns:a="http://schemas.openxmlformats.org/drawingml/2006/main">
-            <a:pPr algn="l">
-              <a:defRPr sz="1275" b="0">
-                <a:solidFill>
-                  <a:srgbClr val="222222"/>
-                </a:solidFill>
-                <a:latin typeface="Arial"/>
-                <a:ea typeface="Arial"/>
-                <a:cs typeface="Arial"/>
-              </a:defRPr>
-            </a:pPr>
-            <a:r>
-              <a:rPr sz="1275" b="0">
-                <a:solidFill>
-                  <a:srgbClr val="222222"/>
-                </a:solidFill>
-                <a:latin typeface="Arial"/>
-                <a:ea typeface="Arial"/>
-                <a:cs typeface="Arial"/>
-              </a:rPr>
-              <a:t>2. Suite: pruebas aprobadas / pruebas ejecutadas × 100. Última verificación: 37/37.</a:t>
-            </a:r>
-          </a:p>
-          <a:p xmlns:a="http://schemas.openxmlformats.org/drawingml/2006/main">
-            <a:r>
-              <a:t/>
-            </a:r>
-          </a:p>
-          <a:p xmlns:a="http://schemas.openxmlformats.org/drawingml/2006/main">
-            <a:pPr algn="l">
-              <a:defRPr sz="1275" b="0">
-                <a:solidFill>
-                  <a:srgbClr val="222222"/>
-                </a:solidFill>
-                <a:latin typeface="Arial"/>
-                <a:ea typeface="Arial"/>
-                <a:cs typeface="Arial"/>
-              </a:defRPr>
-            </a:pPr>
-            <a:r>
-              <a:rPr sz="1275" b="0">
-                <a:solidFill>
-                  <a:srgbClr val="222222"/>
-                </a:solidFill>
-                <a:latin typeface="Arial"/>
-                <a:ea typeface="Arial"/>
-                <a:cs typeface="Arial"/>
-              </a:rPr>
-              <a:t>3. Revisión: cambios del núcleo revisados y probados / cambios del núcleo × 100.</a:t>
-            </a:r>
-          </a:p>
-          <a:p xmlns:a="http://schemas.openxmlformats.org/drawingml/2006/main">
-            <a:r>
-              <a:t/>
-            </a:r>
-          </a:p>
-          <a:p xmlns:a="http://schemas.openxmlformats.org/drawingml/2006/main">
-            <a:pPr algn="l">
-              <a:defRPr sz="1275" b="0">
-                <a:solidFill>
-                  <a:srgbClr val="222222"/>
-                </a:solidFill>
-                <a:latin typeface="Arial"/>
-                <a:ea typeface="Arial"/>
-                <a:cs typeface="Arial"/>
-              </a:defRPr>
-            </a:pPr>
-            <a:r>
-              <a:rPr sz="1275" b="0">
-                <a:solidFill>
-                  <a:srgbClr val="222222"/>
-                </a:solidFill>
-                <a:latin typeface="Arial"/>
-                <a:ea typeface="Arial"/>
-                <a:cs typeface="Arial"/>
-              </a:rPr>
-              <a:t>KRI: requisitos fallidos o sin prueba significativa. Alerta si el valor supera cero.</a:t>
-            </a:r>
-          </a:p>
-          <a:p xmlns:a="http://schemas.openxmlformats.org/drawingml/2006/main">
-            <a:r>
-              <a:t/>
-            </a:r>
-          </a:p>
-          <a:p xmlns:a="http://schemas.openxmlformats.org/drawingml/2006/main">
-            <a:pPr algn="l">
-              <a:defRPr sz="1275" b="0">
-                <a:solidFill>
-                  <a:srgbClr val="222222"/>
-                </a:solidFill>
-                <a:latin typeface="Arial"/>
-                <a:ea typeface="Arial"/>
-                <a:cs typeface="Arial"/>
-              </a:defRPr>
-            </a:pPr>
-            <a:r>
-              <a:rPr sz="1275" b="0">
-                <a:solidFill>
-                  <a:srgbClr val="222222"/>
-                </a:solidFill>
-                <a:latin typeface="Arial"/>
-                <a:ea typeface="Arial"/>
-                <a:cs typeface="Arial"/>
-              </a:rPr>
-              <a:t>Goodhart: no premiar la cantidad de tests; revisar qué comportamiento comprueba cada uno.</a:t>
-            </a:r>
-          </a:p>
-        </p:txBody>
-      </p:sp>
-      <p:sp>
-        <p:nvSpPr>
-          <p:cNvPr id="11" name="policy-rule">
-            <a:extLst xmlns:a="http://schemas.openxmlformats.org/drawingml/2006/main">
-              <a:ext uri="{FF2B5EF4-FFF2-40B4-BE49-F238E27FC236}">
-                <a16:creationId xmlns:a16="http://schemas.microsoft.com/office/drawing/2014/main" id="{6A3B6D69-FA58-4CDF-BE1C-47AC17F104D2}"/>
-              </a:ext>
-            </a:extLst>
-          </p:cNvPr>
-          <p:cNvSpPr>
-            <a:spLocks xmlns:a="http://schemas.openxmlformats.org/drawingml/2006/main" noGrp="1"/>
-          </p:cNvSpPr>
-          <p:nvPr/>
-        </p:nvSpPr>
-        <p:spPr>
-          <a:xfrm xmlns:a="http://schemas.openxmlformats.org/drawingml/2006/main">
-            <a:off x="781050" y="5715000"/>
-            <a:ext cx="10477500" cy="14288"/>
-          </a:xfrm>
-          <a:prstGeom xmlns:a="http://schemas.openxmlformats.org/drawingml/2006/main" prst="rect">
-            <a:avLst/>
-          </a:prstGeom>
-          <a:solidFill xmlns:a="http://schemas.openxmlformats.org/drawingml/2006/main">
-            <a:srgbClr val="B8C2C6"/>
-          </a:solidFill>
-          <a:ln xmlns:a="http://schemas.openxmlformats.org/drawingml/2006/main" w="0">
-            <a:noFill/>
-            <a:prstDash val="solid"/>
-          </a:ln>
-        </p:spPr>
-      </p:sp>
-      <p:sp>
-        <p:nvSpPr>
-          <p:cNvPr id="12" name="ai-policy">
-            <a:extLst xmlns:a="http://schemas.openxmlformats.org/drawingml/2006/main">
-              <a:ext uri="{FF2B5EF4-FFF2-40B4-BE49-F238E27FC236}">
-                <a16:creationId xmlns:a16="http://schemas.microsoft.com/office/drawing/2014/main" id="{35D81E00-D2D1-44BC-87AA-42E62C0A5767}"/>
-              </a:ext>
-            </a:extLst>
-          </p:cNvPr>
-          <p:cNvSpPr>
-            <a:spLocks xmlns:a="http://schemas.openxmlformats.org/drawingml/2006/main" noGrp="1"/>
-          </p:cNvSpPr>
-          <p:nvPr/>
-        </p:nvSpPr>
-        <p:spPr>
-          <a:xfrm xmlns:a="http://schemas.openxmlformats.org/drawingml/2006/main">
-            <a:off x="781050" y="5867400"/>
-            <a:ext cx="10382250" cy="381000"/>
-          </a:xfrm>
-          <a:prstGeom xmlns:a="http://schemas.openxmlformats.org/drawingml/2006/main" prst="rect">
-            <a:avLst/>
-          </a:prstGeom>
-          <a:noFill xmlns:a="http://schemas.openxmlformats.org/drawingml/2006/main"/>
-          <a:ln xmlns:a="http://schemas.openxmlformats.org/drawingml/2006/main" w="0">
-            <a:noFill/>
-            <a:prstDash val="solid"/>
-          </a:ln>
-        </p:spPr>
-        <p:txBody>
-          <a:bodyPr xmlns:a="http://schemas.openxmlformats.org/drawingml/2006/main" lIns="0" tIns="0" rIns="0" bIns="0"/>
-          <a:lstStyle xmlns:a="http://schemas.openxmlformats.org/drawingml/2006/main">
-            <a:defPPr algn="l">
-              <a:defRPr sz="1275" b="0">
-                <a:solidFill>
-                  <a:srgbClr val="333333"/>
-                </a:solidFill>
-                <a:latin typeface="Arial"/>
-                <a:ea typeface="Arial"/>
-                <a:cs typeface="Arial"/>
-              </a:defRPr>
-            </a:defPPr>
-            <a:lvl1pPr algn="l">
-              <a:defRPr sz="1275" b="0">
-                <a:solidFill>
-                  <a:srgbClr val="333333"/>
-                </a:solidFill>
-                <a:latin typeface="Arial"/>
-                <a:ea typeface="Arial"/>
-                <a:cs typeface="Arial"/>
-              </a:defRPr>
-            </a:lvl1pPr>
-            <a:lvl2pPr algn="l">
-              <a:defRPr sz="1275" b="0">
-                <a:solidFill>
-                  <a:srgbClr val="333333"/>
-                </a:solidFill>
-                <a:latin typeface="Arial"/>
-                <a:ea typeface="Arial"/>
-                <a:cs typeface="Arial"/>
-              </a:defRPr>
-            </a:lvl2pPr>
-            <a:lvl3pPr algn="l">
-              <a:defRPr sz="1275" b="0">
-                <a:solidFill>
-                  <a:srgbClr val="333333"/>
-                </a:solidFill>
-                <a:latin typeface="Arial"/>
-                <a:ea typeface="Arial"/>
-                <a:cs typeface="Arial"/>
-              </a:defRPr>
-            </a:lvl3pPr>
-            <a:lvl4pPr algn="l">
-              <a:defRPr sz="1275" b="0">
-                <a:solidFill>
-                  <a:srgbClr val="333333"/>
-                </a:solidFill>
-                <a:latin typeface="Arial"/>
-                <a:ea typeface="Arial"/>
-                <a:cs typeface="Arial"/>
-              </a:defRPr>
-            </a:lvl4pPr>
-            <a:lvl5pPr algn="l">
-              <a:defRPr sz="1275" b="0">
-                <a:solidFill>
-                  <a:srgbClr val="333333"/>
-                </a:solidFill>
-                <a:latin typeface="Arial"/>
-                <a:ea typeface="Arial"/>
-                <a:cs typeface="Arial"/>
-              </a:defRPr>
-            </a:lvl5pPr>
-            <a:lvl6pPr algn="l">
-              <a:defRPr sz="1275" b="0">
-                <a:solidFill>
-                  <a:srgbClr val="333333"/>
-                </a:solidFill>
-                <a:latin typeface="Arial"/>
-                <a:ea typeface="Arial"/>
-                <a:cs typeface="Arial"/>
-              </a:defRPr>
-            </a:lvl6pPr>
-            <a:lvl7pPr algn="l">
-              <a:defRPr sz="1275" b="0">
-                <a:solidFill>
-                  <a:srgbClr val="333333"/>
-                </a:solidFill>
-                <a:latin typeface="Arial"/>
-                <a:ea typeface="Arial"/>
-                <a:cs typeface="Arial"/>
-              </a:defRPr>
-            </a:lvl7pPr>
-            <a:lvl8pPr algn="l">
-              <a:defRPr sz="1275" b="0">
-                <a:solidFill>
-                  <a:srgbClr val="333333"/>
-                </a:solidFill>
-                <a:latin typeface="Arial"/>
-                <a:ea typeface="Arial"/>
-                <a:cs typeface="Arial"/>
-              </a:defRPr>
-            </a:lvl8pPr>
-            <a:lvl9pPr algn="l">
-              <a:defRPr sz="1275" b="0">
-                <a:solidFill>
-                  <a:srgbClr val="333333"/>
-                </a:solidFill>
-                <a:latin typeface="Arial"/>
-                <a:ea typeface="Arial"/>
-                <a:cs typeface="Arial"/>
-              </a:defRPr>
-            </a:lvl9pPr>
-          </a:lstStyle>
-          <a:p xmlns:a="http://schemas.openxmlformats.org/drawingml/2006/main">
-            <a:pPr algn="l">
-              <a:defRPr sz="1275" b="0">
-                <a:solidFill>
-                  <a:srgbClr val="333333"/>
-                </a:solidFill>
-                <a:latin typeface="Arial"/>
-                <a:ea typeface="Arial"/>
-                <a:cs typeface="Arial"/>
-              </a:defRPr>
-            </a:pPr>
-            <a:r>
-              <a:rPr sz="1275" b="0">
-                <a:solidFill>
-                  <a:srgbClr val="333333"/>
-                </a:solidFill>
-                <a:latin typeface="Arial"/>
-                <a:ea typeface="Arial"/>
-                <a:cs typeface="Arial"/>
-              </a:rPr>
-              <a:t>IA: no se integra en esta versión. El código asistido se entiende, revisa y prueba; no se comparten secretos ni datos personales.</a:t>
-            </a:r>
-          </a:p>
-        </p:txBody>
-      </p:sp>
-      <p:sp>
-        <p:nvSpPr>
           <p:cNvPr id="13" name="footer">
             <a:extLst xmlns:a="http://schemas.openxmlformats.org/drawingml/2006/main">
               <a:ext uri="{FF2B5EF4-FFF2-40B4-BE49-F238E27FC236}">
@@ -20232,6 +18904,826 @@
           </a:p>
         </p:txBody>
       </p:sp>
+      <p:sp xmlns:a="http://schemas.openxmlformats.org/drawingml/2006/main">
+        <p:nvSpPr>
+          <p:cNvPr id="15" name="TextBox 14"/>
+          <p:cNvSpPr txBox="1"/>
+          <p:nvPr/>
+        </p:nvSpPr>
+        <p:spPr>
+          <a:xfrm>
+            <a:off x="777240" y="1417320"/>
+            <a:ext cx="10424160" cy="320040"/>
+          </a:xfrm>
+          <a:prstGeom prst="rect">
+            <a:avLst/>
+          </a:prstGeom>
+          <a:noFill/>
+        </p:spPr>
+        <p:txBody>
+          <a:bodyPr wrap="square" lIns="0" rIns="0" tIns="0" bIns="0">
+            <a:spAutoFit/>
+          </a:bodyPr>
+          <a:lstStyle/>
+          <a:p>
+            <a:pPr>
+              <a:defRPr sz="1800" b="1">
+                <a:solidFill>
+                  <a:srgbClr val="202020"/>
+                </a:solidFill>
+                <a:latin typeface="Arial"/>
+              </a:defRPr>
+            </a:pPr>
+            <a:r>
+              <a:t>Riesgos principales</a:t>
+            </a:r>
+          </a:p>
+        </p:txBody>
+      </p:sp>
+      <p:sp xmlns:a="http://schemas.openxmlformats.org/drawingml/2006/main">
+        <p:nvSpPr>
+          <p:cNvPr id="16" name="TextBox 15"/>
+          <p:cNvSpPr txBox="1"/>
+          <p:nvPr/>
+        </p:nvSpPr>
+        <p:spPr>
+          <a:xfrm>
+            <a:off x="777240" y="1773936"/>
+            <a:ext cx="10424160" cy="274320"/>
+          </a:xfrm>
+          <a:prstGeom prst="rect">
+            <a:avLst/>
+          </a:prstGeom>
+          <a:noFill/>
+        </p:spPr>
+        <p:txBody>
+          <a:bodyPr wrap="square" lIns="0" rIns="0" tIns="0" bIns="0">
+            <a:spAutoFit/>
+          </a:bodyPr>
+          <a:lstStyle/>
+          <a:p>
+            <a:pPr>
+              <a:defRPr sz="1100" b="0">
+                <a:solidFill>
+                  <a:srgbClr val="666666"/>
+                </a:solidFill>
+                <a:latin typeface="Arial"/>
+              </a:defRPr>
+            </a:pPr>
+            <a:r>
+              <a:t>P = probabilidad · I = impacto · Respuestas propuestas para el proyecto</a:t>
+            </a:r>
+          </a:p>
+        </p:txBody>
+      </p:sp>
+      <p:sp xmlns:a="http://schemas.openxmlformats.org/drawingml/2006/main">
+        <p:nvSpPr>
+          <p:cNvPr id="17" name="TextBox 16"/>
+          <p:cNvSpPr txBox="1"/>
+          <p:nvPr/>
+        </p:nvSpPr>
+        <p:spPr>
+          <a:xfrm>
+            <a:off x="822960" y="2185416"/>
+            <a:ext cx="2971800" cy="228600"/>
+          </a:xfrm>
+          <a:prstGeom prst="rect">
+            <a:avLst/>
+          </a:prstGeom>
+          <a:noFill/>
+        </p:spPr>
+        <p:txBody>
+          <a:bodyPr wrap="square" lIns="0" rIns="0" tIns="0" bIns="0">
+            <a:spAutoFit/>
+          </a:bodyPr>
+          <a:lstStyle/>
+          <a:p>
+            <a:pPr>
+              <a:defRPr sz="1200" b="1">
+                <a:solidFill>
+                  <a:srgbClr val="202020"/>
+                </a:solidFill>
+                <a:latin typeface="Arial"/>
+              </a:defRPr>
+            </a:pPr>
+            <a:r>
+              <a:t>Reglas de ajedrez incorrectas</a:t>
+            </a:r>
+          </a:p>
+        </p:txBody>
+      </p:sp>
+      <p:sp xmlns:a="http://schemas.openxmlformats.org/drawingml/2006/main">
+        <p:nvSpPr>
+          <p:cNvPr id="18" name="TextBox 17"/>
+          <p:cNvSpPr txBox="1"/>
+          <p:nvPr/>
+        </p:nvSpPr>
+        <p:spPr>
+          <a:xfrm>
+            <a:off x="3840480" y="2185416"/>
+            <a:ext cx="1828800" cy="228600"/>
+          </a:xfrm>
+          <a:prstGeom prst="rect">
+            <a:avLst/>
+          </a:prstGeom>
+          <a:noFill/>
+        </p:spPr>
+        <p:txBody>
+          <a:bodyPr wrap="square" lIns="0" rIns="0" tIns="0" bIns="0">
+            <a:spAutoFit/>
+          </a:bodyPr>
+          <a:lstStyle/>
+          <a:p>
+            <a:pPr>
+              <a:defRPr sz="1100" b="0">
+                <a:solidFill>
+                  <a:srgbClr val="555555"/>
+                </a:solidFill>
+                <a:latin typeface="Arial"/>
+              </a:defRPr>
+            </a:pPr>
+            <a:r>
+              <a:t>P media · I alto</a:t>
+            </a:r>
+          </a:p>
+        </p:txBody>
+      </p:sp>
+      <p:sp xmlns:a="http://schemas.openxmlformats.org/drawingml/2006/main">
+        <p:nvSpPr>
+          <p:cNvPr id="19" name="TextBox 18"/>
+          <p:cNvSpPr txBox="1"/>
+          <p:nvPr/>
+        </p:nvSpPr>
+        <p:spPr>
+          <a:xfrm>
+            <a:off x="5669280" y="2185416"/>
+            <a:ext cx="5394960" cy="320040"/>
+          </a:xfrm>
+          <a:prstGeom prst="rect">
+            <a:avLst/>
+          </a:prstGeom>
+          <a:noFill/>
+        </p:spPr>
+        <p:txBody>
+          <a:bodyPr wrap="square" lIns="0" rIns="0" tIns="0" bIns="0">
+            <a:spAutoFit/>
+          </a:bodyPr>
+          <a:lstStyle/>
+          <a:p>
+            <a:pPr>
+              <a:defRPr sz="1100" b="0">
+                <a:solidFill>
+                  <a:srgbClr val="202020"/>
+                </a:solidFill>
+                <a:latin typeface="Arial"/>
+              </a:defRPr>
+            </a:pPr>
+            <a:r>
+              <a:t>Mitigar: prueba por requisito y revisión de casos límite.</a:t>
+            </a:r>
+          </a:p>
+        </p:txBody>
+      </p:sp>
+      <p:sp xmlns:a="http://schemas.openxmlformats.org/drawingml/2006/main">
+        <p:nvSpPr>
+          <p:cNvPr id="20" name="Rectangle 19"/>
+          <p:cNvSpPr/>
+          <p:nvPr/>
+        </p:nvSpPr>
+        <p:spPr>
+          <a:xfrm>
+            <a:off x="822960" y="2615184"/>
+            <a:ext cx="10469880" cy="9144"/>
+          </a:xfrm>
+          <a:prstGeom prst="rect">
+            <a:avLst/>
+          </a:prstGeom>
+          <a:solidFill>
+            <a:srgbClr val="DDDDDD"/>
+          </a:solidFill>
+          <a:ln>
+            <a:noFill/>
+          </a:ln>
+        </p:spPr>
+        <p:style>
+          <a:lnRef idx="1">
+            <a:schemeClr val="accent1"/>
+          </a:lnRef>
+          <a:fillRef idx="3">
+            <a:schemeClr val="accent1"/>
+          </a:fillRef>
+          <a:effectRef idx="2">
+            <a:schemeClr val="accent1"/>
+          </a:effectRef>
+          <a:fontRef idx="minor">
+            <a:schemeClr val="lt1"/>
+          </a:fontRef>
+        </p:style>
+        <p:txBody>
+          <a:bodyPr rtlCol="0" anchor="ctr"/>
+          <a:lstStyle/>
+          <a:p>
+            <a:pPr algn="ctr"/>
+          </a:p>
+        </p:txBody>
+      </p:sp>
+      <p:sp xmlns:a="http://schemas.openxmlformats.org/drawingml/2006/main">
+        <p:nvSpPr>
+          <p:cNvPr id="21" name="TextBox 20"/>
+          <p:cNvSpPr txBox="1"/>
+          <p:nvPr/>
+        </p:nvSpPr>
+        <p:spPr>
+          <a:xfrm>
+            <a:off x="822960" y="2834640"/>
+            <a:ext cx="2971800" cy="228600"/>
+          </a:xfrm>
+          <a:prstGeom prst="rect">
+            <a:avLst/>
+          </a:prstGeom>
+          <a:noFill/>
+        </p:spPr>
+        <p:txBody>
+          <a:bodyPr wrap="square" lIns="0" rIns="0" tIns="0" bIns="0">
+            <a:spAutoFit/>
+          </a:bodyPr>
+          <a:lstStyle/>
+          <a:p>
+            <a:pPr>
+              <a:defRPr sz="1200" b="1">
+                <a:solidFill>
+                  <a:srgbClr val="202020"/>
+                </a:solidFill>
+                <a:latin typeface="Arial"/>
+              </a:defRPr>
+            </a:pPr>
+            <a:r>
+              <a:t>Pruebas débiles o alteradas</a:t>
+            </a:r>
+          </a:p>
+        </p:txBody>
+      </p:sp>
+      <p:sp xmlns:a="http://schemas.openxmlformats.org/drawingml/2006/main">
+        <p:nvSpPr>
+          <p:cNvPr id="22" name="TextBox 21"/>
+          <p:cNvSpPr txBox="1"/>
+          <p:nvPr/>
+        </p:nvSpPr>
+        <p:spPr>
+          <a:xfrm>
+            <a:off x="3840480" y="2834640"/>
+            <a:ext cx="1828800" cy="228600"/>
+          </a:xfrm>
+          <a:prstGeom prst="rect">
+            <a:avLst/>
+          </a:prstGeom>
+          <a:noFill/>
+        </p:spPr>
+        <p:txBody>
+          <a:bodyPr wrap="square" lIns="0" rIns="0" tIns="0" bIns="0">
+            <a:spAutoFit/>
+          </a:bodyPr>
+          <a:lstStyle/>
+          <a:p>
+            <a:pPr>
+              <a:defRPr sz="1100" b="0">
+                <a:solidFill>
+                  <a:srgbClr val="555555"/>
+                </a:solidFill>
+                <a:latin typeface="Arial"/>
+              </a:defRPr>
+            </a:pPr>
+            <a:r>
+              <a:t>P media · I alto</a:t>
+            </a:r>
+          </a:p>
+        </p:txBody>
+      </p:sp>
+      <p:sp xmlns:a="http://schemas.openxmlformats.org/drawingml/2006/main">
+        <p:nvSpPr>
+          <p:cNvPr id="23" name="TextBox 22"/>
+          <p:cNvSpPr txBox="1"/>
+          <p:nvPr/>
+        </p:nvSpPr>
+        <p:spPr>
+          <a:xfrm>
+            <a:off x="5669280" y="2834640"/>
+            <a:ext cx="5394960" cy="320040"/>
+          </a:xfrm>
+          <a:prstGeom prst="rect">
+            <a:avLst/>
+          </a:prstGeom>
+          <a:noFill/>
+        </p:spPr>
+        <p:txBody>
+          <a:bodyPr wrap="square" lIns="0" rIns="0" tIns="0" bIns="0">
+            <a:spAutoFit/>
+          </a:bodyPr>
+          <a:lstStyle/>
+          <a:p>
+            <a:pPr>
+              <a:defRPr sz="1100" b="0">
+                <a:solidFill>
+                  <a:srgbClr val="202020"/>
+                </a:solidFill>
+                <a:latin typeface="Arial"/>
+              </a:defRPr>
+            </a:pPr>
+            <a:r>
+              <a:t>Mitigar: revisar aserciones y conservar regresiones.</a:t>
+            </a:r>
+          </a:p>
+        </p:txBody>
+      </p:sp>
+      <p:sp xmlns:a="http://schemas.openxmlformats.org/drawingml/2006/main">
+        <p:nvSpPr>
+          <p:cNvPr id="24" name="Rectangle 23"/>
+          <p:cNvSpPr/>
+          <p:nvPr/>
+        </p:nvSpPr>
+        <p:spPr>
+          <a:xfrm>
+            <a:off x="822960" y="3264408"/>
+            <a:ext cx="10469880" cy="9144"/>
+          </a:xfrm>
+          <a:prstGeom prst="rect">
+            <a:avLst/>
+          </a:prstGeom>
+          <a:solidFill>
+            <a:srgbClr val="DDDDDD"/>
+          </a:solidFill>
+          <a:ln>
+            <a:noFill/>
+          </a:ln>
+        </p:spPr>
+        <p:style>
+          <a:lnRef idx="1">
+            <a:schemeClr val="accent1"/>
+          </a:lnRef>
+          <a:fillRef idx="3">
+            <a:schemeClr val="accent1"/>
+          </a:fillRef>
+          <a:effectRef idx="2">
+            <a:schemeClr val="accent1"/>
+          </a:effectRef>
+          <a:fontRef idx="minor">
+            <a:schemeClr val="lt1"/>
+          </a:fontRef>
+        </p:style>
+        <p:txBody>
+          <a:bodyPr rtlCol="0" anchor="ctr"/>
+          <a:lstStyle/>
+          <a:p>
+            <a:pPr algn="ctr"/>
+          </a:p>
+        </p:txBody>
+      </p:sp>
+      <p:sp xmlns:a="http://schemas.openxmlformats.org/drawingml/2006/main">
+        <p:nvSpPr>
+          <p:cNvPr id="25" name="TextBox 24"/>
+          <p:cNvSpPr txBox="1"/>
+          <p:nvPr/>
+        </p:nvSpPr>
+        <p:spPr>
+          <a:xfrm>
+            <a:off x="822960" y="3483864"/>
+            <a:ext cx="2971800" cy="228600"/>
+          </a:xfrm>
+          <a:prstGeom prst="rect">
+            <a:avLst/>
+          </a:prstGeom>
+          <a:noFill/>
+        </p:spPr>
+        <p:txBody>
+          <a:bodyPr wrap="square" lIns="0" rIns="0" tIns="0" bIns="0">
+            <a:spAutoFit/>
+          </a:bodyPr>
+          <a:lstStyle/>
+          <a:p>
+            <a:pPr>
+              <a:defRPr sz="1200" b="1">
+                <a:solidFill>
+                  <a:srgbClr val="202020"/>
+                </a:solidFill>
+                <a:latin typeface="Arial"/>
+              </a:defRPr>
+            </a:pPr>
+            <a:r>
+              <a:t>Pérdida de código o integración tardía</a:t>
+            </a:r>
+          </a:p>
+        </p:txBody>
+      </p:sp>
+      <p:sp xmlns:a="http://schemas.openxmlformats.org/drawingml/2006/main">
+        <p:nvSpPr>
+          <p:cNvPr id="26" name="TextBox 25"/>
+          <p:cNvSpPr txBox="1"/>
+          <p:nvPr/>
+        </p:nvSpPr>
+        <p:spPr>
+          <a:xfrm>
+            <a:off x="3840480" y="3483864"/>
+            <a:ext cx="1828800" cy="228600"/>
+          </a:xfrm>
+          <a:prstGeom prst="rect">
+            <a:avLst/>
+          </a:prstGeom>
+          <a:noFill/>
+        </p:spPr>
+        <p:txBody>
+          <a:bodyPr wrap="square" lIns="0" rIns="0" tIns="0" bIns="0">
+            <a:spAutoFit/>
+          </a:bodyPr>
+          <a:lstStyle/>
+          <a:p>
+            <a:pPr>
+              <a:defRPr sz="1100" b="0">
+                <a:solidFill>
+                  <a:srgbClr val="555555"/>
+                </a:solidFill>
+                <a:latin typeface="Arial"/>
+              </a:defRPr>
+            </a:pPr>
+            <a:r>
+              <a:t>P baja · I alto</a:t>
+            </a:r>
+          </a:p>
+        </p:txBody>
+      </p:sp>
+      <p:sp xmlns:a="http://schemas.openxmlformats.org/drawingml/2006/main">
+        <p:nvSpPr>
+          <p:cNvPr id="27" name="TextBox 26"/>
+          <p:cNvSpPr txBox="1"/>
+          <p:nvPr/>
+        </p:nvSpPr>
+        <p:spPr>
+          <a:xfrm>
+            <a:off x="5669280" y="3483864"/>
+            <a:ext cx="5394960" cy="320040"/>
+          </a:xfrm>
+          <a:prstGeom prst="rect">
+            <a:avLst/>
+          </a:prstGeom>
+          <a:noFill/>
+        </p:spPr>
+        <p:txBody>
+          <a:bodyPr wrap="square" lIns="0" rIns="0" tIns="0" bIns="0">
+            <a:spAutoFit/>
+          </a:bodyPr>
+          <a:lstStyle/>
+          <a:p>
+            <a:pPr>
+              <a:defRPr sz="1100" b="0">
+                <a:solidFill>
+                  <a:srgbClr val="202020"/>
+                </a:solidFill>
+                <a:latin typeface="Arial"/>
+              </a:defRPr>
+            </a:pPr>
+            <a:r>
+              <a:t>Mitigar: repositorio remoto y suite antes de entregar.</a:t>
+            </a:r>
+          </a:p>
+        </p:txBody>
+      </p:sp>
+      <p:sp xmlns:a="http://schemas.openxmlformats.org/drawingml/2006/main">
+        <p:nvSpPr>
+          <p:cNvPr id="28" name="Rectangle 27"/>
+          <p:cNvSpPr/>
+          <p:nvPr/>
+        </p:nvSpPr>
+        <p:spPr>
+          <a:xfrm>
+            <a:off x="822960" y="3913632"/>
+            <a:ext cx="10469880" cy="9144"/>
+          </a:xfrm>
+          <a:prstGeom prst="rect">
+            <a:avLst/>
+          </a:prstGeom>
+          <a:solidFill>
+            <a:srgbClr val="DDDDDD"/>
+          </a:solidFill>
+          <a:ln>
+            <a:noFill/>
+          </a:ln>
+        </p:spPr>
+        <p:style>
+          <a:lnRef idx="1">
+            <a:schemeClr val="accent1"/>
+          </a:lnRef>
+          <a:fillRef idx="3">
+            <a:schemeClr val="accent1"/>
+          </a:fillRef>
+          <a:effectRef idx="2">
+            <a:schemeClr val="accent1"/>
+          </a:effectRef>
+          <a:fontRef idx="minor">
+            <a:schemeClr val="lt1"/>
+          </a:fontRef>
+        </p:style>
+        <p:txBody>
+          <a:bodyPr rtlCol="0" anchor="ctr"/>
+          <a:lstStyle/>
+          <a:p>
+            <a:pPr algn="ctr"/>
+          </a:p>
+        </p:txBody>
+      </p:sp>
+      <p:sp xmlns:a="http://schemas.openxmlformats.org/drawingml/2006/main">
+        <p:nvSpPr>
+          <p:cNvPr id="29" name="TextBox 28"/>
+          <p:cNvSpPr txBox="1"/>
+          <p:nvPr/>
+        </p:nvSpPr>
+        <p:spPr>
+          <a:xfrm>
+            <a:off x="822960" y="4133087"/>
+            <a:ext cx="2971800" cy="228600"/>
+          </a:xfrm>
+          <a:prstGeom prst="rect">
+            <a:avLst/>
+          </a:prstGeom>
+          <a:noFill/>
+        </p:spPr>
+        <p:txBody>
+          <a:bodyPr wrap="square" lIns="0" rIns="0" tIns="0" bIns="0">
+            <a:spAutoFit/>
+          </a:bodyPr>
+          <a:lstStyle/>
+          <a:p>
+            <a:pPr>
+              <a:defRPr sz="1200" b="1">
+                <a:solidFill>
+                  <a:srgbClr val="202020"/>
+                </a:solidFill>
+                <a:latin typeface="Arial"/>
+              </a:defRPr>
+            </a:pPr>
+            <a:r>
+              <a:t>Conocimiento concentrado</a:t>
+            </a:r>
+          </a:p>
+        </p:txBody>
+      </p:sp>
+      <p:sp xmlns:a="http://schemas.openxmlformats.org/drawingml/2006/main">
+        <p:nvSpPr>
+          <p:cNvPr id="30" name="TextBox 29"/>
+          <p:cNvSpPr txBox="1"/>
+          <p:nvPr/>
+        </p:nvSpPr>
+        <p:spPr>
+          <a:xfrm>
+            <a:off x="3840480" y="4133087"/>
+            <a:ext cx="1828800" cy="228600"/>
+          </a:xfrm>
+          <a:prstGeom prst="rect">
+            <a:avLst/>
+          </a:prstGeom>
+          <a:noFill/>
+        </p:spPr>
+        <p:txBody>
+          <a:bodyPr wrap="square" lIns="0" rIns="0" tIns="0" bIns="0">
+            <a:spAutoFit/>
+          </a:bodyPr>
+          <a:lstStyle/>
+          <a:p>
+            <a:pPr>
+              <a:defRPr sz="1100" b="0">
+                <a:solidFill>
+                  <a:srgbClr val="555555"/>
+                </a:solidFill>
+                <a:latin typeface="Arial"/>
+              </a:defRPr>
+            </a:pPr>
+            <a:r>
+              <a:t>P media · I medio</a:t>
+            </a:r>
+          </a:p>
+        </p:txBody>
+      </p:sp>
+      <p:sp xmlns:a="http://schemas.openxmlformats.org/drawingml/2006/main">
+        <p:nvSpPr>
+          <p:cNvPr id="31" name="TextBox 30"/>
+          <p:cNvSpPr txBox="1"/>
+          <p:nvPr/>
+        </p:nvSpPr>
+        <p:spPr>
+          <a:xfrm>
+            <a:off x="5669280" y="4133087"/>
+            <a:ext cx="5394960" cy="320040"/>
+          </a:xfrm>
+          <a:prstGeom prst="rect">
+            <a:avLst/>
+          </a:prstGeom>
+          <a:noFill/>
+        </p:spPr>
+        <p:txBody>
+          <a:bodyPr wrap="square" lIns="0" rIns="0" tIns="0" bIns="0">
+            <a:spAutoFit/>
+          </a:bodyPr>
+          <a:lstStyle/>
+          <a:p>
+            <a:pPr>
+              <a:defRPr sz="1100" b="0">
+                <a:solidFill>
+                  <a:srgbClr val="202020"/>
+                </a:solidFill>
+                <a:latin typeface="Arial"/>
+              </a:defRPr>
+            </a:pPr>
+            <a:r>
+              <a:t>Mitigar: revisión compartida y explicación del núcleo.</a:t>
+            </a:r>
+          </a:p>
+        </p:txBody>
+      </p:sp>
+      <p:sp xmlns:a="http://schemas.openxmlformats.org/drawingml/2006/main">
+        <p:nvSpPr>
+          <p:cNvPr id="32" name="Rectangle 31"/>
+          <p:cNvSpPr/>
+          <p:nvPr/>
+        </p:nvSpPr>
+        <p:spPr>
+          <a:xfrm>
+            <a:off x="822960" y="4562855"/>
+            <a:ext cx="10469880" cy="9144"/>
+          </a:xfrm>
+          <a:prstGeom prst="rect">
+            <a:avLst/>
+          </a:prstGeom>
+          <a:solidFill>
+            <a:srgbClr val="DDDDDD"/>
+          </a:solidFill>
+          <a:ln>
+            <a:noFill/>
+          </a:ln>
+        </p:spPr>
+        <p:style>
+          <a:lnRef idx="1">
+            <a:schemeClr val="accent1"/>
+          </a:lnRef>
+          <a:fillRef idx="3">
+            <a:schemeClr val="accent1"/>
+          </a:fillRef>
+          <a:effectRef idx="2">
+            <a:schemeClr val="accent1"/>
+          </a:effectRef>
+          <a:fontRef idx="minor">
+            <a:schemeClr val="lt1"/>
+          </a:fontRef>
+        </p:style>
+        <p:txBody>
+          <a:bodyPr rtlCol="0" anchor="ctr"/>
+          <a:lstStyle/>
+          <a:p>
+            <a:pPr algn="ctr"/>
+          </a:p>
+        </p:txBody>
+      </p:sp>
+      <p:sp xmlns:a="http://schemas.openxmlformats.org/drawingml/2006/main">
+        <p:nvSpPr>
+          <p:cNvPr id="33" name="TextBox 32"/>
+          <p:cNvSpPr txBox="1"/>
+          <p:nvPr/>
+        </p:nvSpPr>
+        <p:spPr>
+          <a:xfrm>
+            <a:off x="822960" y="4782312"/>
+            <a:ext cx="2971800" cy="228600"/>
+          </a:xfrm>
+          <a:prstGeom prst="rect">
+            <a:avLst/>
+          </a:prstGeom>
+          <a:noFill/>
+        </p:spPr>
+        <p:txBody>
+          <a:bodyPr wrap="square" lIns="0" rIns="0" tIns="0" bIns="0">
+            <a:spAutoFit/>
+          </a:bodyPr>
+          <a:lstStyle/>
+          <a:p>
+            <a:pPr>
+              <a:defRPr sz="1200" b="1">
+                <a:solidFill>
+                  <a:srgbClr val="202020"/>
+                </a:solidFill>
+                <a:latin typeface="Arial"/>
+              </a:defRPr>
+            </a:pPr>
+            <a:r>
+              <a:t>Exposición de una clave si se integra IA</a:t>
+            </a:r>
+          </a:p>
+        </p:txBody>
+      </p:sp>
+      <p:sp xmlns:a="http://schemas.openxmlformats.org/drawingml/2006/main">
+        <p:nvSpPr>
+          <p:cNvPr id="34" name="TextBox 33"/>
+          <p:cNvSpPr txBox="1"/>
+          <p:nvPr/>
+        </p:nvSpPr>
+        <p:spPr>
+          <a:xfrm>
+            <a:off x="3840480" y="4782312"/>
+            <a:ext cx="1828800" cy="228600"/>
+          </a:xfrm>
+          <a:prstGeom prst="rect">
+            <a:avLst/>
+          </a:prstGeom>
+          <a:noFill/>
+        </p:spPr>
+        <p:txBody>
+          <a:bodyPr wrap="square" lIns="0" rIns="0" tIns="0" bIns="0">
+            <a:spAutoFit/>
+          </a:bodyPr>
+          <a:lstStyle/>
+          <a:p>
+            <a:pPr>
+              <a:defRPr sz="1100" b="0">
+                <a:solidFill>
+                  <a:srgbClr val="555555"/>
+                </a:solidFill>
+                <a:latin typeface="Arial"/>
+              </a:defRPr>
+            </a:pPr>
+            <a:r>
+              <a:t>P baja hoy · I alto</a:t>
+            </a:r>
+          </a:p>
+        </p:txBody>
+      </p:sp>
+      <p:sp xmlns:a="http://schemas.openxmlformats.org/drawingml/2006/main">
+        <p:nvSpPr>
+          <p:cNvPr id="35" name="TextBox 34"/>
+          <p:cNvSpPr txBox="1"/>
+          <p:nvPr/>
+        </p:nvSpPr>
+        <p:spPr>
+          <a:xfrm>
+            <a:off x="5669280" y="4782312"/>
+            <a:ext cx="5394960" cy="320040"/>
+          </a:xfrm>
+          <a:prstGeom prst="rect">
+            <a:avLst/>
+          </a:prstGeom>
+          <a:noFill/>
+        </p:spPr>
+        <p:txBody>
+          <a:bodyPr wrap="square" lIns="0" rIns="0" tIns="0" bIns="0">
+            <a:spAutoFit/>
+          </a:bodyPr>
+          <a:lstStyle/>
+          <a:p>
+            <a:pPr>
+              <a:defRPr sz="1100" b="0">
+                <a:solidFill>
+                  <a:srgbClr val="202020"/>
+                </a:solidFill>
+                <a:latin typeface="Arial"/>
+              </a:defRPr>
+            </a:pPr>
+            <a:r>
+              <a:t>Evitar: IA fuera del alcance; si cambia, clave fuera del repo.</a:t>
+            </a:r>
+          </a:p>
+        </p:txBody>
+      </p:sp>
+      <p:sp xmlns:a="http://schemas.openxmlformats.org/drawingml/2006/main">
+        <p:nvSpPr>
+          <p:cNvPr id="36" name="TextBox 35"/>
+          <p:cNvSpPr txBox="1"/>
+          <p:nvPr/>
+        </p:nvSpPr>
+        <p:spPr>
+          <a:xfrm>
+            <a:off x="777240" y="5742432"/>
+            <a:ext cx="10469880" cy="365760"/>
+          </a:xfrm>
+          <a:prstGeom prst="rect">
+            <a:avLst/>
+          </a:prstGeom>
+          <a:noFill/>
+        </p:spPr>
+        <p:txBody>
+          <a:bodyPr wrap="square" lIns="0" rIns="0" tIns="0" bIns="0">
+            <a:spAutoFit/>
+          </a:bodyPr>
+          <a:lstStyle/>
+          <a:p>
+            <a:pPr>
+              <a:defRPr sz="1000" b="0">
+                <a:solidFill>
+                  <a:srgbClr val="555555"/>
+                </a:solidFill>
+                <a:latin typeface="Arial"/>
+              </a:defRPr>
+            </a:pPr>
+            <a:r>
+              <a:t>Estimación inicial del grupo; revisar probabilidad e impacto si cambia el alcance.</a:t>
+            </a:r>
+          </a:p>
+        </p:txBody>
+      </p:sp>
     </p:spTree>
     <p:extLst>
       <p:ext uri="{BB962C8B-B14F-4D97-AF65-F5344CB8AC3E}">
@@ -20239,6 +19731,706 @@
       </p:ext>
     </p:extLst>
   </p:cSld>
+</p:sld>
+</file>
+
+<file path=ppt/slides/slide9.xml><?xml version="1.0" encoding="utf-8"?>
+<p:sld xmlns:a="http://schemas.openxmlformats.org/drawingml/2006/main" xmlns:p="http://schemas.openxmlformats.org/presentationml/2006/main" xmlns:r="http://schemas.openxmlformats.org/officeDocument/2006/relationships">
+  <p:cSld>
+    <p:spTree>
+      <p:nvGrpSpPr>
+        <p:cNvPr id="1" name=""/>
+        <p:cNvGrpSpPr/>
+        <p:nvPr/>
+      </p:nvGrpSpPr>
+      <p:grpSpPr/>
+      <p:sp>
+        <p:nvSpPr>
+          <p:cNvPr id="2" name="Rectangle 1"/>
+          <p:cNvSpPr/>
+          <p:nvPr/>
+        </p:nvSpPr>
+        <p:spPr>
+          <a:xfrm>
+            <a:off x="0" y="0"/>
+            <a:ext cx="155448" cy="6858000"/>
+          </a:xfrm>
+          <a:prstGeom prst="rect">
+            <a:avLst/>
+          </a:prstGeom>
+          <a:solidFill>
+            <a:srgbClr val="111111"/>
+          </a:solidFill>
+          <a:ln>
+            <a:noFill/>
+          </a:ln>
+        </p:spPr>
+        <p:style>
+          <a:lnRef idx="1">
+            <a:schemeClr val="accent1"/>
+          </a:lnRef>
+          <a:fillRef idx="3">
+            <a:schemeClr val="accent1"/>
+          </a:fillRef>
+          <a:effectRef idx="2">
+            <a:schemeClr val="accent1"/>
+          </a:effectRef>
+          <a:fontRef idx="minor">
+            <a:schemeClr val="lt1"/>
+          </a:fontRef>
+        </p:style>
+        <p:txBody>
+          <a:bodyPr rtlCol="0" anchor="ctr"/>
+          <a:lstStyle/>
+          <a:p>
+            <a:pPr algn="ctr"/>
+          </a:p>
+        </p:txBody>
+      </p:sp>
+      <p:sp>
+        <p:nvSpPr>
+          <p:cNvPr id="3" name="TextBox 2"/>
+          <p:cNvSpPr txBox="1"/>
+          <p:nvPr/>
+        </p:nvSpPr>
+        <p:spPr>
+          <a:xfrm>
+            <a:off x="667512" y="402336"/>
+            <a:ext cx="10671048" cy="566928"/>
+          </a:xfrm>
+          <a:prstGeom prst="rect">
+            <a:avLst/>
+          </a:prstGeom>
+          <a:noFill/>
+        </p:spPr>
+        <p:txBody>
+          <a:bodyPr wrap="square" lIns="0" rIns="0" tIns="0" bIns="0">
+            <a:spAutoFit/>
+          </a:bodyPr>
+          <a:lstStyle/>
+          <a:p>
+            <a:pPr>
+              <a:defRPr sz="2600" b="1">
+                <a:solidFill>
+                  <a:srgbClr val="111111"/>
+                </a:solidFill>
+                <a:latin typeface="Arial"/>
+              </a:defRPr>
+            </a:pPr>
+            <a:r>
+              <a:t>Meta, preguntas e indicadores</a:t>
+            </a:r>
+          </a:p>
+        </p:txBody>
+      </p:sp>
+      <p:sp>
+        <p:nvSpPr>
+          <p:cNvPr id="4" name="Rectangle 3"/>
+          <p:cNvSpPr/>
+          <p:nvPr/>
+        </p:nvSpPr>
+        <p:spPr>
+          <a:xfrm>
+            <a:off x="667512" y="1078992"/>
+            <a:ext cx="10863072" cy="18288"/>
+          </a:xfrm>
+          <a:prstGeom prst="rect">
+            <a:avLst/>
+          </a:prstGeom>
+          <a:solidFill>
+            <a:srgbClr val="222222"/>
+          </a:solidFill>
+          <a:ln>
+            <a:noFill/>
+          </a:ln>
+        </p:spPr>
+        <p:style>
+          <a:lnRef idx="1">
+            <a:schemeClr val="accent1"/>
+          </a:lnRef>
+          <a:fillRef idx="3">
+            <a:schemeClr val="accent1"/>
+          </a:fillRef>
+          <a:effectRef idx="2">
+            <a:schemeClr val="accent1"/>
+          </a:effectRef>
+          <a:fontRef idx="minor">
+            <a:schemeClr val="lt1"/>
+          </a:fontRef>
+        </p:style>
+        <p:txBody>
+          <a:bodyPr rtlCol="0" anchor="ctr"/>
+          <a:lstStyle/>
+          <a:p>
+            <a:pPr algn="ctr"/>
+          </a:p>
+        </p:txBody>
+      </p:sp>
+      <p:sp>
+        <p:nvSpPr>
+          <p:cNvPr id="5" name="TextBox 4"/>
+          <p:cNvSpPr txBox="1"/>
+          <p:nvPr/>
+        </p:nvSpPr>
+        <p:spPr>
+          <a:xfrm>
+            <a:off x="667512" y="6428232"/>
+            <a:ext cx="6665976" cy="210312"/>
+          </a:xfrm>
+          <a:prstGeom prst="rect">
+            <a:avLst/>
+          </a:prstGeom>
+          <a:noFill/>
+        </p:spPr>
+        <p:txBody>
+          <a:bodyPr wrap="square" lIns="0" rIns="0" tIns="0" bIns="0">
+            <a:spAutoFit/>
+          </a:bodyPr>
+          <a:lstStyle/>
+          <a:p>
+            <a:pPr>
+              <a:defRPr sz="900" b="0">
+                <a:solidFill>
+                  <a:srgbClr val="666666"/>
+                </a:solidFill>
+                <a:latin typeface="Arial"/>
+              </a:defRPr>
+            </a:pPr>
+            <a:r>
+              <a:t>09  ·  TPO AJEDREZ</a:t>
+            </a:r>
+          </a:p>
+        </p:txBody>
+      </p:sp>
+      <p:sp>
+        <p:nvSpPr>
+          <p:cNvPr id="6" name="TextBox 5"/>
+          <p:cNvSpPr txBox="1"/>
+          <p:nvPr/>
+        </p:nvSpPr>
+        <p:spPr>
+          <a:xfrm>
+            <a:off x="777240" y="1353312"/>
+            <a:ext cx="10515600" cy="274320"/>
+          </a:xfrm>
+          <a:prstGeom prst="rect">
+            <a:avLst/>
+          </a:prstGeom>
+          <a:noFill/>
+        </p:spPr>
+        <p:txBody>
+          <a:bodyPr wrap="square" lIns="0" rIns="0" tIns="0" bIns="0">
+            <a:spAutoFit/>
+          </a:bodyPr>
+          <a:lstStyle/>
+          <a:p>
+            <a:pPr>
+              <a:defRPr sz="1600" b="1">
+                <a:solidFill>
+                  <a:srgbClr val="202020"/>
+                </a:solidFill>
+                <a:latin typeface="Arial"/>
+              </a:defRPr>
+            </a:pPr>
+            <a:r>
+              <a:t>Meta: entregar un ajedrez correcto y verificable.</a:t>
+            </a:r>
+          </a:p>
+        </p:txBody>
+      </p:sp>
+      <p:sp>
+        <p:nvSpPr>
+          <p:cNvPr id="7" name="TextBox 6"/>
+          <p:cNvSpPr txBox="1"/>
+          <p:nvPr/>
+        </p:nvSpPr>
+        <p:spPr>
+          <a:xfrm>
+            <a:off x="777240" y="1700784"/>
+            <a:ext cx="10515600" cy="365760"/>
+          </a:xfrm>
+          <a:prstGeom prst="rect">
+            <a:avLst/>
+          </a:prstGeom>
+          <a:noFill/>
+        </p:spPr>
+        <p:txBody>
+          <a:bodyPr wrap="square" lIns="0" rIns="0" tIns="0" bIns="0">
+            <a:spAutoFit/>
+          </a:bodyPr>
+          <a:lstStyle/>
+          <a:p>
+            <a:pPr>
+              <a:defRPr sz="1100" b="0">
+                <a:solidFill>
+                  <a:srgbClr val="444444"/>
+                </a:solidFill>
+                <a:latin typeface="Arial"/>
+              </a:defRPr>
+            </a:pPr>
+            <a:r>
+              <a:t>Preguntas: ¿cada requisito obligatorio tiene una prueba significativa? ¿La suite detecta regresiones? ¿Los cambios del núcleo se revisan?</a:t>
+            </a:r>
+          </a:p>
+        </p:txBody>
+      </p:sp>
+      <p:sp>
+        <p:nvSpPr>
+          <p:cNvPr id="8" name="TextBox 7"/>
+          <p:cNvSpPr txBox="1"/>
+          <p:nvPr/>
+        </p:nvSpPr>
+        <p:spPr>
+          <a:xfrm>
+            <a:off x="822960" y="2221992"/>
+            <a:ext cx="1874519" cy="347472"/>
+          </a:xfrm>
+          <a:prstGeom prst="rect">
+            <a:avLst/>
+          </a:prstGeom>
+          <a:noFill/>
+        </p:spPr>
+        <p:txBody>
+          <a:bodyPr wrap="square" lIns="0" rIns="0" tIns="0" bIns="0">
+            <a:spAutoFit/>
+          </a:bodyPr>
+          <a:lstStyle/>
+          <a:p>
+            <a:pPr>
+              <a:defRPr sz="1300" b="1">
+                <a:solidFill>
+                  <a:srgbClr val="202020"/>
+                </a:solidFill>
+                <a:latin typeface="Arial"/>
+              </a:defRPr>
+            </a:pPr>
+            <a:r>
+              <a:t>1  Cobertura de requisitos</a:t>
+            </a:r>
+          </a:p>
+        </p:txBody>
+      </p:sp>
+      <p:sp>
+        <p:nvSpPr>
+          <p:cNvPr id="9" name="TextBox 8"/>
+          <p:cNvSpPr txBox="1"/>
+          <p:nvPr/>
+        </p:nvSpPr>
+        <p:spPr>
+          <a:xfrm>
+            <a:off x="2743200" y="2221992"/>
+            <a:ext cx="8503920" cy="713232"/>
+          </a:xfrm>
+          <a:prstGeom prst="rect">
+            <a:avLst/>
+          </a:prstGeom>
+          <a:noFill/>
+        </p:spPr>
+        <p:txBody>
+          <a:bodyPr wrap="square" lIns="0" rIns="0" tIns="0" bIns="0">
+            <a:spAutoFit/>
+          </a:bodyPr>
+          <a:lstStyle/>
+          <a:p>
+            <a:pPr>
+              <a:defRPr sz="1019" b="0">
+                <a:solidFill>
+                  <a:srgbClr val="333333"/>
+                </a:solidFill>
+                <a:latin typeface="Arial"/>
+              </a:defRPr>
+            </a:pPr>
+            <a:r>
+              <a:t>Requisitos obligatorios con prueba significativa aprobada / requisitos obligatorios × 100.</a:t>
+            </a:r>
+          </a:p>
+          <a:p>
+            <a:pPr>
+              <a:defRPr sz="1019" b="0">
+                <a:solidFill>
+                  <a:srgbClr val="333333"/>
+                </a:solidFill>
+                <a:latin typeface="Arial"/>
+              </a:defRPr>
+            </a:pPr>
+            <a:r>
+              <a:t>Responsable propuesto: quien mantiene las pruebas. Datos: consigna y relación requisito–test. Meta: 100% antes de entregar.</a:t>
+            </a:r>
+          </a:p>
+          <a:p>
+            <a:pPr>
+              <a:defRPr sz="1019" b="0">
+                <a:solidFill>
+                  <a:srgbClr val="333333"/>
+                </a:solidFill>
+                <a:latin typeface="Arial"/>
+              </a:defRPr>
+            </a:pPr>
+            <a:r>
+              <a:t>Riesgo Goodhart: tests sin aserciones útiles. Control: revisar qué comportamiento falla si se rompe.</a:t>
+            </a:r>
+          </a:p>
+        </p:txBody>
+      </p:sp>
+      <p:sp>
+        <p:nvSpPr>
+          <p:cNvPr id="10" name="Rectangle 9"/>
+          <p:cNvSpPr/>
+          <p:nvPr/>
+        </p:nvSpPr>
+        <p:spPr>
+          <a:xfrm>
+            <a:off x="822960" y="3017520"/>
+            <a:ext cx="10424160" cy="9144"/>
+          </a:xfrm>
+          <a:prstGeom prst="rect">
+            <a:avLst/>
+          </a:prstGeom>
+          <a:solidFill>
+            <a:srgbClr val="DDDDDD"/>
+          </a:solidFill>
+          <a:ln>
+            <a:noFill/>
+          </a:ln>
+        </p:spPr>
+        <p:style>
+          <a:lnRef idx="1">
+            <a:schemeClr val="accent1"/>
+          </a:lnRef>
+          <a:fillRef idx="3">
+            <a:schemeClr val="accent1"/>
+          </a:fillRef>
+          <a:effectRef idx="2">
+            <a:schemeClr val="accent1"/>
+          </a:effectRef>
+          <a:fontRef idx="minor">
+            <a:schemeClr val="lt1"/>
+          </a:fontRef>
+        </p:style>
+        <p:txBody>
+          <a:bodyPr rtlCol="0" anchor="ctr"/>
+          <a:lstStyle/>
+          <a:p>
+            <a:pPr algn="ctr"/>
+          </a:p>
+        </p:txBody>
+      </p:sp>
+      <p:sp>
+        <p:nvSpPr>
+          <p:cNvPr id="11" name="TextBox 10"/>
+          <p:cNvSpPr txBox="1"/>
+          <p:nvPr/>
+        </p:nvSpPr>
+        <p:spPr>
+          <a:xfrm>
+            <a:off x="822960" y="3127248"/>
+            <a:ext cx="1874519" cy="347472"/>
+          </a:xfrm>
+          <a:prstGeom prst="rect">
+            <a:avLst/>
+          </a:prstGeom>
+          <a:noFill/>
+        </p:spPr>
+        <p:txBody>
+          <a:bodyPr wrap="square" lIns="0" rIns="0" tIns="0" bIns="0">
+            <a:spAutoFit/>
+          </a:bodyPr>
+          <a:lstStyle/>
+          <a:p>
+            <a:pPr>
+              <a:defRPr sz="1300" b="1">
+                <a:solidFill>
+                  <a:srgbClr val="202020"/>
+                </a:solidFill>
+                <a:latin typeface="Arial"/>
+              </a:defRPr>
+            </a:pPr>
+            <a:r>
+              <a:t>2  Éxito de la suite</a:t>
+            </a:r>
+          </a:p>
+        </p:txBody>
+      </p:sp>
+      <p:sp>
+        <p:nvSpPr>
+          <p:cNvPr id="12" name="TextBox 11"/>
+          <p:cNvSpPr txBox="1"/>
+          <p:nvPr/>
+        </p:nvSpPr>
+        <p:spPr>
+          <a:xfrm>
+            <a:off x="2743200" y="3127248"/>
+            <a:ext cx="8503920" cy="713232"/>
+          </a:xfrm>
+          <a:prstGeom prst="rect">
+            <a:avLst/>
+          </a:prstGeom>
+          <a:noFill/>
+        </p:spPr>
+        <p:txBody>
+          <a:bodyPr wrap="square" lIns="0" rIns="0" tIns="0" bIns="0">
+            <a:spAutoFit/>
+          </a:bodyPr>
+          <a:lstStyle/>
+          <a:p>
+            <a:pPr>
+              <a:defRPr sz="1019" b="0">
+                <a:solidFill>
+                  <a:srgbClr val="333333"/>
+                </a:solidFill>
+                <a:latin typeface="Arial"/>
+              </a:defRPr>
+            </a:pPr>
+            <a:r>
+              <a:t>Pruebas aprobadas / pruebas ejecutadas × 100.</a:t>
+            </a:r>
+          </a:p>
+          <a:p>
+            <a:pPr>
+              <a:defRPr sz="1019" b="0">
+                <a:solidFill>
+                  <a:srgbClr val="333333"/>
+                </a:solidFill>
+                <a:latin typeface="Arial"/>
+              </a:defRPr>
+            </a:pPr>
+            <a:r>
+              <a:t>Responsable propuesto: quien integra. Datos: salida de unittest. Meta: 100% en cada integración y entrega.</a:t>
+            </a:r>
+          </a:p>
+          <a:p>
+            <a:pPr>
+              <a:defRPr sz="1019" b="0">
+                <a:solidFill>
+                  <a:srgbClr val="333333"/>
+                </a:solidFill>
+                <a:latin typeface="Arial"/>
+              </a:defRPr>
+            </a:pPr>
+            <a:r>
+              <a:t>Riesgo Goodhart: borrar o debilitar el test que falla. Control: conservar regresiones y revisar cambios de tests.</a:t>
+            </a:r>
+          </a:p>
+        </p:txBody>
+      </p:sp>
+      <p:sp>
+        <p:nvSpPr>
+          <p:cNvPr id="13" name="Rectangle 12"/>
+          <p:cNvSpPr/>
+          <p:nvPr/>
+        </p:nvSpPr>
+        <p:spPr>
+          <a:xfrm>
+            <a:off x="822960" y="3922776"/>
+            <a:ext cx="10424160" cy="9144"/>
+          </a:xfrm>
+          <a:prstGeom prst="rect">
+            <a:avLst/>
+          </a:prstGeom>
+          <a:solidFill>
+            <a:srgbClr val="DDDDDD"/>
+          </a:solidFill>
+          <a:ln>
+            <a:noFill/>
+          </a:ln>
+        </p:spPr>
+        <p:style>
+          <a:lnRef idx="1">
+            <a:schemeClr val="accent1"/>
+          </a:lnRef>
+          <a:fillRef idx="3">
+            <a:schemeClr val="accent1"/>
+          </a:fillRef>
+          <a:effectRef idx="2">
+            <a:schemeClr val="accent1"/>
+          </a:effectRef>
+          <a:fontRef idx="minor">
+            <a:schemeClr val="lt1"/>
+          </a:fontRef>
+        </p:style>
+        <p:txBody>
+          <a:bodyPr rtlCol="0" anchor="ctr"/>
+          <a:lstStyle/>
+          <a:p>
+            <a:pPr algn="ctr"/>
+          </a:p>
+        </p:txBody>
+      </p:sp>
+      <p:sp>
+        <p:nvSpPr>
+          <p:cNvPr id="14" name="TextBox 13"/>
+          <p:cNvSpPr txBox="1"/>
+          <p:nvPr/>
+        </p:nvSpPr>
+        <p:spPr>
+          <a:xfrm>
+            <a:off x="822960" y="4032504"/>
+            <a:ext cx="1874519" cy="347472"/>
+          </a:xfrm>
+          <a:prstGeom prst="rect">
+            <a:avLst/>
+          </a:prstGeom>
+          <a:noFill/>
+        </p:spPr>
+        <p:txBody>
+          <a:bodyPr wrap="square" lIns="0" rIns="0" tIns="0" bIns="0">
+            <a:spAutoFit/>
+          </a:bodyPr>
+          <a:lstStyle/>
+          <a:p>
+            <a:pPr>
+              <a:defRPr sz="1300" b="1">
+                <a:solidFill>
+                  <a:srgbClr val="202020"/>
+                </a:solidFill>
+                <a:latin typeface="Arial"/>
+              </a:defRPr>
+            </a:pPr>
+            <a:r>
+              <a:t>3  Revisión de cambios</a:t>
+            </a:r>
+          </a:p>
+        </p:txBody>
+      </p:sp>
+      <p:sp>
+        <p:nvSpPr>
+          <p:cNvPr id="15" name="TextBox 14"/>
+          <p:cNvSpPr txBox="1"/>
+          <p:nvPr/>
+        </p:nvSpPr>
+        <p:spPr>
+          <a:xfrm>
+            <a:off x="2743200" y="4032504"/>
+            <a:ext cx="8503920" cy="713232"/>
+          </a:xfrm>
+          <a:prstGeom prst="rect">
+            <a:avLst/>
+          </a:prstGeom>
+          <a:noFill/>
+        </p:spPr>
+        <p:txBody>
+          <a:bodyPr wrap="square" lIns="0" rIns="0" tIns="0" bIns="0">
+            <a:spAutoFit/>
+          </a:bodyPr>
+          <a:lstStyle/>
+          <a:p>
+            <a:pPr>
+              <a:defRPr sz="1019" b="0">
+                <a:solidFill>
+                  <a:srgbClr val="333333"/>
+                </a:solidFill>
+                <a:latin typeface="Arial"/>
+              </a:defRPr>
+            </a:pPr>
+            <a:r>
+              <a:t>Cambios de reglas revisados y probados / total de cambios de reglas × 100.</a:t>
+            </a:r>
+          </a:p>
+          <a:p>
+            <a:pPr>
+              <a:defRPr sz="1019" b="0">
+                <a:solidFill>
+                  <a:srgbClr val="333333"/>
+                </a:solidFill>
+                <a:latin typeface="Arial"/>
+              </a:defRPr>
+            </a:pPr>
+            <a:r>
+              <a:t>Responsable propuesto: integrador y par revisor. Datos: cambios del repositorio y salida de tests. Meta: 100% en cada integración.</a:t>
+            </a:r>
+          </a:p>
+          <a:p>
+            <a:pPr>
+              <a:defRPr sz="1019" b="0">
+                <a:solidFill>
+                  <a:srgbClr val="333333"/>
+                </a:solidFill>
+                <a:latin typeface="Arial"/>
+              </a:defRPr>
+            </a:pPr>
+            <a:r>
+              <a:t>Riesgo Goodhart: aprobar sin leer. Control: explicar la regla revisada y comprobar la prueba.</a:t>
+            </a:r>
+          </a:p>
+        </p:txBody>
+      </p:sp>
+      <p:sp>
+        <p:nvSpPr>
+          <p:cNvPr id="16" name="TextBox 15"/>
+          <p:cNvSpPr txBox="1"/>
+          <p:nvPr/>
+        </p:nvSpPr>
+        <p:spPr>
+          <a:xfrm>
+            <a:off x="822960" y="5010912"/>
+            <a:ext cx="10469880" cy="493776"/>
+          </a:xfrm>
+          <a:prstGeom prst="rect">
+            <a:avLst/>
+          </a:prstGeom>
+          <a:noFill/>
+        </p:spPr>
+        <p:txBody>
+          <a:bodyPr wrap="square" lIns="0" rIns="0" tIns="0" bIns="0">
+            <a:spAutoFit/>
+          </a:bodyPr>
+          <a:lstStyle/>
+          <a:p>
+            <a:pPr>
+              <a:defRPr sz="1100" b="1">
+                <a:solidFill>
+                  <a:srgbClr val="202020"/>
+                </a:solidFill>
+                <a:latin typeface="Arial"/>
+              </a:defRPr>
+            </a:pPr>
+            <a:r>
+              <a:t>KRI: requisitos obligatorios fallidos o sin prueba significativa. Alerta &gt; 0: pausar ampliaciones y corregir el núcleo.</a:t>
+            </a:r>
+          </a:p>
+        </p:txBody>
+      </p:sp>
+      <p:sp>
+        <p:nvSpPr>
+          <p:cNvPr id="17" name="TextBox 16"/>
+          <p:cNvSpPr txBox="1"/>
+          <p:nvPr/>
+        </p:nvSpPr>
+        <p:spPr>
+          <a:xfrm>
+            <a:off x="822960" y="5559552"/>
+            <a:ext cx="10469880" cy="475488"/>
+          </a:xfrm>
+          <a:prstGeom prst="rect">
+            <a:avLst/>
+          </a:prstGeom>
+          <a:noFill/>
+        </p:spPr>
+        <p:txBody>
+          <a:bodyPr wrap="square" lIns="0" rIns="0" tIns="0" bIns="0">
+            <a:spAutoFit/>
+          </a:bodyPr>
+          <a:lstStyle/>
+          <a:p>
+            <a:pPr>
+              <a:defRPr sz="1000" b="0">
+                <a:solidFill>
+                  <a:srgbClr val="555555"/>
+                </a:solidFill>
+                <a:latin typeface="Arial"/>
+              </a:defRPr>
+            </a:pPr>
+            <a:r>
+              <a:t>No se fija una cantidad objetivo de tests: se revisa su vínculo con requisitos y resultados observables. Propuesta basada en Unidad 6, diap. 12–13.</a:t>
+            </a:r>
+          </a:p>
+        </p:txBody>
+      </p:sp>
+    </p:spTree>
+  </p:cSld>
+  <p:clrMapOvr>
+    <a:masterClrMapping/>
+  </p:clrMapOvr>
 </p:sld>
 </file>
 

</xml_diff>